<commit_message>
Add Beat 4 Software Factory slides to the Innovate 2026 deck
Insert three slides after the Big-O Auditor demo: the Software Factory
(factory diagram), assess/plan/execute/validate with the three human gates
(pipeline diagram), and the canvas with the cost story. Diagrams are
rendered from assets/beat-4-*.svg in the deck's dark palette. Speaker notes
added; page numbers updated to N / 11.

Co-authored-by: Copilot App <223556219+Copilot@users.noreply.github.com>
Copilot-Session: f6cc3d2c-6b44-4542-8af0-81148774cea7
</commit_message>
<xml_diff>
--- a/Innovate2026-AgenticWorkflows.pptx
+++ b/Innovate2026-AgenticWorkflows.pptx
@@ -13,6 +13,9 @@
     <p:sldId id="258" r:id="rId4"/>
     <p:sldId id="259" r:id="rId5"/>
     <p:sldId id="260" r:id="rId6"/>
+    <p:sldId id="264" r:id="rId15"/>
+    <p:sldId id="265" r:id="rId16"/>
+    <p:sldId id="266" r:id="rId17"/>
     <p:sldId id="261" r:id="rId7"/>
     <p:sldId id="262" r:id="rId8"/>
     <p:sldId id="263" r:id="rId9"/>
@@ -328,6 +331,128 @@
 </p:notes>
 </file>
 
+<file path=ppt/notesSlides/notesSlide10.xml><?xml version="1.0" encoding="utf-8"?>
+<p:notes xmlns:a="http://schemas.openxmlformats.org/drawingml/2006/main" xmlns:p="http://schemas.openxmlformats.org/presentationml/2006/main" xmlns:r="http://schemas.openxmlformats.org/officeDocument/2006/relationships">
+  <p:cSld>
+    <p:spTree>
+      <p:nvGrpSpPr>
+        <p:cNvPr id="1" name=""/>
+        <p:cNvGrpSpPr/>
+        <p:nvPr/>
+      </p:nvGrpSpPr>
+      <p:grpSpPr>
+        <a:xfrm>
+          <a:off x="0" y="0"/>
+          <a:ext cx="0" cy="0"/>
+          <a:chOff x="0" y="0"/>
+          <a:chExt cx="0" cy="0"/>
+        </a:xfrm>
+      </p:grpSpPr>
+      <p:sp>
+        <p:nvSpPr>
+          <p:cNvPr id="3" name="Notes Placeholder 2"/>
+          <p:cNvSpPr>
+            <a:spLocks noGrp="1"/>
+          </p:cNvSpPr>
+          <p:nvPr>
+            <p:ph type="body" idx="1"/>
+          </p:nvPr>
+        </p:nvSpPr>
+        <p:spPr/>
+        <p:txBody>
+          <a:bodyPr/>
+          <a:lstStyle/>
+          <a:p>
+            <a:r>
+              <a:t>Same order as GitHub Copilot app modernization (assess, plan, execute, validate), built with our own gh-aw agents and standard Java tools. It does not run that product and is not a supported product feature.</a:t>
+            </a:r>
+          </a:p>
+          <a:p>
+            <a:r>
+              <a:t>Assess: a /modernize issue starts it. Tools only, no AI: tests on JDK 8, dependency tree, jdeps/jdeprscan, SpotBugs, OpenRewrite dry run, OSV.dev. Two read-only analyst agents turn the facts into findings with stable IDs. Gate 1: a human approves the Assessment Report, including the predicted cost per stage.</a:t>
+            </a:r>
+          </a:p>
+          <a:p>
+            <a:r>
+              <a:t>Plan: a planner agent writes plan.md in a plan PR; a deterministic check confirms every finding ID is owned by a step. Gate 2: a human merges the plan. Only Markdown and evidence land in main.</a:t>
+            </a:r>
+          </a:p>
+          <a:p>
+            <a:r>
+              <a:t>Execute and validate: build-upgrader then code-fixer (one writer at a time), verify on JDK 21 (no AI), Spec and Standards reviewers in parallel, finalize posts actual vs predicted cost. Gate 3: a human approves the Implementation PR with a review, without merging, so the demo can repeat.</a:t>
+            </a:r>
+          </a:p>
+        </p:txBody>
+      </p:sp>
+    </p:spTree>
+  </p:cSld>
+  <p:clrMapOvr>
+    <a:masterClrMapping/>
+  </p:clrMapOvr>
+</p:notes>
+</file>
+
+<file path=ppt/notesSlides/notesSlide11.xml><?xml version="1.0" encoding="utf-8"?>
+<p:notes xmlns:a="http://schemas.openxmlformats.org/drawingml/2006/main" xmlns:p="http://schemas.openxmlformats.org/presentationml/2006/main" xmlns:r="http://schemas.openxmlformats.org/officeDocument/2006/relationships">
+  <p:cSld>
+    <p:spTree>
+      <p:nvGrpSpPr>
+        <p:cNvPr id="1" name=""/>
+        <p:cNvGrpSpPr/>
+        <p:nvPr/>
+      </p:nvGrpSpPr>
+      <p:grpSpPr>
+        <a:xfrm>
+          <a:off x="0" y="0"/>
+          <a:ext cx="0" cy="0"/>
+          <a:chOff x="0" y="0"/>
+          <a:chExt cx="0" cy="0"/>
+        </a:xfrm>
+      </p:grpSpPr>
+      <p:sp>
+        <p:nvSpPr>
+          <p:cNvPr id="3" name="Notes Placeholder 2"/>
+          <p:cNvSpPr>
+            <a:spLocks noGrp="1"/>
+          </p:cNvSpPr>
+          <p:nvPr>
+            <p:ph type="body" idx="1"/>
+          </p:nvPr>
+        </p:nvSpPr>
+        <p:spPr/>
+        <p:txBody>
+          <a:bodyPr/>
+          <a:lstStyle/>
+          <a:p>
+            <a:r>
+              <a:t>In the canvas, the token and the three gates are direct human clicks that never pass through AI. Deploy, Update template, Explain the report and Troubleshoot send a prompt to the Copilot agent in the session, which does the work in the chat and asks before it pushes anything.</a:t>
+            </a:r>
+          </a:p>
+          <a:p>
+            <a:r>
+              <a:t>Progress is real: bars count completed jobs and steps from the GitHub Actions API.</a:t>
+            </a:r>
+          </a:p>
+          <a:p>
+            <a:r>
+              <a:t>Cost: plan for about 200 AI credits (about $2) per full run; threat detection is about 30% of it. Runner time is about 85 minutes, free on a public fork, $0.006 per minute on a private repository. The Assessment Report predicts the cost of every stage before gate 1; finalize posts actual vs predicted before gate 3.</a:t>
+            </a:r>
+          </a:p>
+          <a:p>
+            <a:r>
+              <a:t>Because the full run takes about an hour, pre-run it before the meeting and replay it with Open an existing request.</a:t>
+            </a:r>
+          </a:p>
+        </p:txBody>
+      </p:sp>
+    </p:spTree>
+  </p:cSld>
+  <p:clrMapOvr>
+    <a:masterClrMapping/>
+  </p:clrMapOvr>
+</p:notes>
+</file>
+
 <file path=ppt/notesSlides/notesSlide2.xml><?xml version="1.0" encoding="utf-8"?>
 <p:notes xmlns:a="http://schemas.openxmlformats.org/drawingml/2006/main" xmlns:r="http://schemas.openxmlformats.org/officeDocument/2006/relationships" xmlns:p="http://schemas.openxmlformats.org/presentationml/2006/main">
   <p:cSld>
@@ -909,6 +1034,67 @@
         <p14:creationId xmlns:p14="http://schemas.microsoft.com/office/powerpoint/2010/main" val="1024086991"/>
       </p:ext>
     </p:extLst>
+  </p:cSld>
+  <p:clrMapOvr>
+    <a:masterClrMapping/>
+  </p:clrMapOvr>
+</p:notes>
+</file>
+
+<file path=ppt/notesSlides/notesSlide9.xml><?xml version="1.0" encoding="utf-8"?>
+<p:notes xmlns:a="http://schemas.openxmlformats.org/drawingml/2006/main" xmlns:p="http://schemas.openxmlformats.org/presentationml/2006/main" xmlns:r="http://schemas.openxmlformats.org/officeDocument/2006/relationships">
+  <p:cSld>
+    <p:spTree>
+      <p:nvGrpSpPr>
+        <p:cNvPr id="1" name=""/>
+        <p:cNvGrpSpPr/>
+        <p:nvPr/>
+      </p:nvGrpSpPr>
+      <p:grpSpPr>
+        <a:xfrm>
+          <a:off x="0" y="0"/>
+          <a:ext cx="0" cy="0"/>
+          <a:chOff x="0" y="0"/>
+          <a:chExt cx="0" cy="0"/>
+        </a:xfrm>
+      </p:grpSpPr>
+      <p:sp>
+        <p:nvSpPr>
+          <p:cNvPr id="3" name="Notes Placeholder 2"/>
+          <p:cNvSpPr>
+            <a:spLocks noGrp="1"/>
+          </p:cNvSpPr>
+          <p:nvPr>
+            <p:ph type="body" idx="1"/>
+          </p:nvPr>
+        </p:nvSpPr>
+        <p:spPr/>
+        <p:txBody>
+          <a:bodyPr/>
+          <a:lstStyle/>
+          <a:p>
+            <a:r>
+              <a:t>Beat 4 is standalone; it does not need Beats 1-3.</a:t>
+            </a:r>
+          </a:p>
+          <a:p>
+            <a:r>
+              <a:t>The factory (lenvolk/gh-aw-dryrun) holds three things: the repository catalog (templates/catalog.json), the Java modernization template (gh-aw agent workflows, orchestrator workflows, custom agents, skills, scripts, deploy.ps1) and the Software Factory canvas in the GitHub Copilot app.</a:t>
+            </a:r>
+          </a:p>
+          <a:p>
+            <a:r>
+              <a:t>Deploy copies the template into the nominated target (lenvolk/java-migration-copilot-samples). The workflows run there, in its GitHub Actions; the canvas monitors them with live progress bars, like one dashboard over many pipelines.</a:t>
+            </a:r>
+          </a:p>
+          <a:p>
+            <a:r>
+              <a:t>Only nominated repositories may spend minutes and AI credits: JTicket is listed but not nominated, so it is greyed out.</a:t>
+            </a:r>
+          </a:p>
+        </p:txBody>
+      </p:sp>
+    </p:spTree>
   </p:cSld>
   <p:clrMapOvr>
     <a:masterClrMapping/>
@@ -2870,6 +3056,2992 @@
 </p:sld>
 </file>
 
+<file path=ppt/slides/slide10.xml><?xml version="1.0" encoding="utf-8"?>
+<p:sld xmlns:a="http://schemas.openxmlformats.org/drawingml/2006/main" xmlns:p="http://schemas.openxmlformats.org/presentationml/2006/main" xmlns:r="http://schemas.openxmlformats.org/officeDocument/2006/relationships">
+  <p:cSld>
+    <p:bg>
+      <p:bgPr>
+        <a:solidFill>
+          <a:srgbClr val="0D1117"/>
+        </a:solidFill>
+        <a:effectLst/>
+      </p:bgPr>
+    </p:bg>
+    <p:spTree>
+      <p:nvGrpSpPr>
+        <p:cNvPr id="1" name=""/>
+        <p:cNvGrpSpPr/>
+        <p:nvPr/>
+      </p:nvGrpSpPr>
+      <p:grpSpPr/>
+      <p:sp>
+        <p:nvSpPr>
+          <p:cNvPr id="2" name="Rectangle 1"/>
+          <p:cNvSpPr/>
+          <p:nvPr/>
+        </p:nvSpPr>
+        <p:spPr>
+          <a:xfrm>
+            <a:off x="0" y="0"/>
+            <a:ext cx="12191695" cy="36576"/>
+          </a:xfrm>
+          <a:prstGeom prst="rect">
+            <a:avLst/>
+          </a:prstGeom>
+          <a:solidFill>
+            <a:srgbClr val="238636"/>
+          </a:solidFill>
+          <a:ln>
+            <a:noFill/>
+          </a:ln>
+          <a:effectLst/>
+        </p:spPr>
+        <p:style>
+          <a:lnRef idx="1">
+            <a:schemeClr val="accent1"/>
+          </a:lnRef>
+          <a:fillRef idx="3">
+            <a:schemeClr val="accent1"/>
+          </a:fillRef>
+          <a:effectRef idx="2">
+            <a:schemeClr val="accent1"/>
+          </a:effectRef>
+          <a:fontRef idx="minor">
+            <a:schemeClr val="lt1"/>
+          </a:fontRef>
+        </p:style>
+        <p:txBody>
+          <a:bodyPr rtlCol="0" anchor="ctr"/>
+          <a:lstStyle/>
+          <a:p>
+            <a:pPr algn="ctr"/>
+          </a:p>
+        </p:txBody>
+      </p:sp>
+      <p:sp>
+        <p:nvSpPr>
+          <p:cNvPr id="3" name="TextBox 2"/>
+          <p:cNvSpPr txBox="1"/>
+          <p:nvPr/>
+        </p:nvSpPr>
+        <p:spPr>
+          <a:xfrm>
+            <a:off x="731520" y="6400800"/>
+            <a:ext cx="7315200" cy="320040"/>
+          </a:xfrm>
+          <a:prstGeom prst="rect">
+            <a:avLst/>
+          </a:prstGeom>
+          <a:noFill/>
+        </p:spPr>
+        <p:txBody>
+          <a:bodyPr wrap="square" anchor="ctr">
+            <a:spAutoFit/>
+          </a:bodyPr>
+          <a:lstStyle/>
+          <a:p>
+            <a:pPr algn="l"/>
+            <a:r>
+              <a:rPr sz="1000" b="0" i="0">
+                <a:solidFill>
+                  <a:srgbClr val="484F58"/>
+                </a:solidFill>
+                <a:latin typeface="Segoe UI"/>
+                <a:ea typeface="Segoe UI"/>
+                <a:cs typeface="Segoe UI"/>
+              </a:rPr>
+              <a:t>Innovate 2026  ·  ADO/GitHub with Microsoft</a:t>
+            </a:r>
+          </a:p>
+        </p:txBody>
+      </p:sp>
+      <p:sp>
+        <p:nvSpPr>
+          <p:cNvPr id="4" name="Text 2"/>
+          <p:cNvSpPr txBox="1"/>
+          <p:nvPr/>
+        </p:nvSpPr>
+        <p:spPr>
+          <a:xfrm>
+            <a:off x="11155680" y="6446520"/>
+            <a:ext cx="822960" cy="274320"/>
+          </a:xfrm>
+          <a:prstGeom prst="rect">
+            <a:avLst/>
+          </a:prstGeom>
+          <a:noFill/>
+        </p:spPr>
+        <p:txBody>
+          <a:bodyPr wrap="square" anchor="ctr">
+            <a:spAutoFit/>
+          </a:bodyPr>
+          <a:lstStyle/>
+          <a:p>
+            <a:pPr algn="r"/>
+            <a:r>
+              <a:rPr sz="1000" b="0" i="0">
+                <a:solidFill>
+                  <a:srgbClr val="484F58"/>
+                </a:solidFill>
+                <a:latin typeface="Segoe UI"/>
+                <a:ea typeface="Segoe UI"/>
+                <a:cs typeface="Segoe UI"/>
+              </a:rPr>
+              <a:t>7 / 11</a:t>
+            </a:r>
+          </a:p>
+        </p:txBody>
+      </p:sp>
+      <p:sp>
+        <p:nvSpPr>
+          <p:cNvPr id="5" name="TextBox 4"/>
+          <p:cNvSpPr txBox="1"/>
+          <p:nvPr/>
+        </p:nvSpPr>
+        <p:spPr>
+          <a:xfrm>
+            <a:off x="731520" y="320040"/>
+            <a:ext cx="10058400" cy="640080"/>
+          </a:xfrm>
+          <a:prstGeom prst="rect">
+            <a:avLst/>
+          </a:prstGeom>
+          <a:noFill/>
+        </p:spPr>
+        <p:txBody>
+          <a:bodyPr wrap="square" anchor="ctr">
+            <a:spAutoFit/>
+          </a:bodyPr>
+          <a:lstStyle/>
+          <a:p>
+            <a:pPr algn="l"/>
+            <a:r>
+              <a:rPr sz="3800" b="1" i="0">
+                <a:solidFill>
+                  <a:srgbClr val="E6EDF3"/>
+                </a:solidFill>
+                <a:latin typeface="Segoe UI"/>
+                <a:ea typeface="Segoe UI"/>
+                <a:cs typeface="Segoe UI"/>
+              </a:rPr>
+              <a:t>Assess → Plan → Execute → Validate</a:t>
+            </a:r>
+          </a:p>
+        </p:txBody>
+      </p:sp>
+      <p:sp>
+        <p:nvSpPr>
+          <p:cNvPr id="6" name="TextBox 5"/>
+          <p:cNvSpPr txBox="1"/>
+          <p:nvPr/>
+        </p:nvSpPr>
+        <p:spPr>
+          <a:xfrm>
+            <a:off x="731520" y="914400"/>
+            <a:ext cx="10515600" cy="365760"/>
+          </a:xfrm>
+          <a:prstGeom prst="rect">
+            <a:avLst/>
+          </a:prstGeom>
+          <a:noFill/>
+        </p:spPr>
+        <p:txBody>
+          <a:bodyPr wrap="square" anchor="ctr">
+            <a:spAutoFit/>
+          </a:bodyPr>
+          <a:lstStyle/>
+          <a:p>
+            <a:pPr algn="l"/>
+            <a:r>
+              <a:rPr sz="1800" b="0" i="1">
+                <a:solidFill>
+                  <a:srgbClr val="8B949E"/>
+                </a:solidFill>
+                <a:latin typeface="Segoe UI"/>
+                <a:ea typeface="Segoe UI"/>
+                <a:cs typeface="Segoe UI"/>
+              </a:rPr>
+              <a:t>Tools measure the facts, gh-aw agents do the judgment work, a human approves each step</a:t>
+            </a:r>
+          </a:p>
+        </p:txBody>
+      </p:sp>
+      <p:sp>
+        <p:nvSpPr>
+          <p:cNvPr id="7" name="Rounded Rectangle 6"/>
+          <p:cNvSpPr/>
+          <p:nvPr/>
+        </p:nvSpPr>
+        <p:spPr>
+          <a:xfrm>
+            <a:off x="758952" y="1591056"/>
+            <a:ext cx="8043394" cy="4663440"/>
+          </a:xfrm>
+          <a:prstGeom prst="roundRect">
+            <a:avLst>
+              <a:gd name="adj" fmla="val 2352"/>
+            </a:avLst>
+          </a:prstGeom>
+          <a:solidFill>
+            <a:srgbClr val="000000">
+              <a:alpha val="40000"/>
+            </a:srgbClr>
+          </a:solidFill>
+          <a:ln>
+            <a:noFill/>
+          </a:ln>
+          <a:effectLst/>
+        </p:spPr>
+        <p:style>
+          <a:lnRef idx="1">
+            <a:schemeClr val="accent1"/>
+          </a:lnRef>
+          <a:fillRef idx="3">
+            <a:schemeClr val="accent1"/>
+          </a:fillRef>
+          <a:effectRef idx="2">
+            <a:schemeClr val="accent1"/>
+          </a:effectRef>
+          <a:fontRef idx="minor">
+            <a:schemeClr val="lt1"/>
+          </a:fontRef>
+        </p:style>
+        <p:txBody>
+          <a:bodyPr rtlCol="0" anchor="ctr"/>
+          <a:lstStyle/>
+          <a:p>
+            <a:pPr algn="ctr"/>
+          </a:p>
+        </p:txBody>
+      </p:sp>
+      <p:sp>
+        <p:nvSpPr>
+          <p:cNvPr id="8" name="Rounded Rectangle 7"/>
+          <p:cNvSpPr/>
+          <p:nvPr/>
+        </p:nvSpPr>
+        <p:spPr>
+          <a:xfrm>
+            <a:off x="731520" y="1554480"/>
+            <a:ext cx="8043394" cy="4663440"/>
+          </a:xfrm>
+          <a:prstGeom prst="roundRect">
+            <a:avLst>
+              <a:gd name="adj" fmla="val 2352"/>
+            </a:avLst>
+          </a:prstGeom>
+          <a:solidFill>
+            <a:srgbClr val="161B22"/>
+          </a:solidFill>
+          <a:ln w="6350">
+            <a:solidFill>
+              <a:srgbClr val="30363D"/>
+            </a:solidFill>
+          </a:ln>
+          <a:effectLst/>
+        </p:spPr>
+        <p:style>
+          <a:lnRef idx="1">
+            <a:schemeClr val="accent1"/>
+          </a:lnRef>
+          <a:fillRef idx="3">
+            <a:schemeClr val="accent1"/>
+          </a:fillRef>
+          <a:effectRef idx="2">
+            <a:schemeClr val="accent1"/>
+          </a:effectRef>
+          <a:fontRef idx="minor">
+            <a:schemeClr val="lt1"/>
+          </a:fontRef>
+        </p:style>
+        <p:txBody>
+          <a:bodyPr rtlCol="0" anchor="ctr"/>
+          <a:lstStyle/>
+          <a:p>
+            <a:pPr algn="ctr"/>
+          </a:p>
+        </p:txBody>
+      </p:sp>
+      <p:pic>
+        <p:nvPicPr>
+          <p:cNvPr id="9" name="Picture 8" descr="beat-4-pipeline-dark.png"/>
+          <p:cNvPicPr>
+            <a:picLocks noChangeAspect="1"/>
+          </p:cNvPicPr>
+          <p:nvPr/>
+        </p:nvPicPr>
+        <p:blipFill>
+          <a:blip r:embed="rId2"/>
+          <a:stretch>
+            <a:fillRect/>
+          </a:stretch>
+        </p:blipFill>
+        <p:spPr>
+          <a:xfrm>
+            <a:off x="804672" y="1627632"/>
+            <a:ext cx="7897090" cy="4517136"/>
+          </a:xfrm>
+          <a:prstGeom prst="rect">
+            <a:avLst/>
+          </a:prstGeom>
+        </p:spPr>
+      </p:pic>
+      <p:sp>
+        <p:nvSpPr>
+          <p:cNvPr id="10" name="Rounded Rectangle 9"/>
+          <p:cNvSpPr/>
+          <p:nvPr/>
+        </p:nvSpPr>
+        <p:spPr>
+          <a:xfrm>
+            <a:off x="9094954" y="1591056"/>
+            <a:ext cx="2389909" cy="1402080"/>
+          </a:xfrm>
+          <a:prstGeom prst="roundRect">
+            <a:avLst>
+              <a:gd name="adj" fmla="val 7826"/>
+            </a:avLst>
+          </a:prstGeom>
+          <a:solidFill>
+            <a:srgbClr val="000000">
+              <a:alpha val="40000"/>
+            </a:srgbClr>
+          </a:solidFill>
+          <a:ln>
+            <a:noFill/>
+          </a:ln>
+          <a:effectLst/>
+        </p:spPr>
+        <p:style>
+          <a:lnRef idx="1">
+            <a:schemeClr val="accent1"/>
+          </a:lnRef>
+          <a:fillRef idx="3">
+            <a:schemeClr val="accent1"/>
+          </a:fillRef>
+          <a:effectRef idx="2">
+            <a:schemeClr val="accent1"/>
+          </a:effectRef>
+          <a:fontRef idx="minor">
+            <a:schemeClr val="lt1"/>
+          </a:fontRef>
+        </p:style>
+        <p:txBody>
+          <a:bodyPr rtlCol="0" anchor="ctr"/>
+          <a:lstStyle/>
+          <a:p>
+            <a:pPr algn="ctr"/>
+          </a:p>
+        </p:txBody>
+      </p:sp>
+      <p:sp>
+        <p:nvSpPr>
+          <p:cNvPr id="11" name="Rounded Rectangle 10"/>
+          <p:cNvSpPr/>
+          <p:nvPr/>
+        </p:nvSpPr>
+        <p:spPr>
+          <a:xfrm>
+            <a:off x="9067522" y="1554480"/>
+            <a:ext cx="2389909" cy="1402080"/>
+          </a:xfrm>
+          <a:prstGeom prst="roundRect">
+            <a:avLst>
+              <a:gd name="adj" fmla="val 7826"/>
+            </a:avLst>
+          </a:prstGeom>
+          <a:solidFill>
+            <a:srgbClr val="21262D"/>
+          </a:solidFill>
+          <a:ln w="6350">
+            <a:solidFill>
+              <a:srgbClr val="30363D"/>
+            </a:solidFill>
+          </a:ln>
+          <a:effectLst/>
+        </p:spPr>
+        <p:style>
+          <a:lnRef idx="1">
+            <a:schemeClr val="accent1"/>
+          </a:lnRef>
+          <a:fillRef idx="3">
+            <a:schemeClr val="accent1"/>
+          </a:fillRef>
+          <a:effectRef idx="2">
+            <a:schemeClr val="accent1"/>
+          </a:effectRef>
+          <a:fontRef idx="minor">
+            <a:schemeClr val="lt1"/>
+          </a:fontRef>
+        </p:style>
+        <p:txBody>
+          <a:bodyPr rtlCol="0" anchor="ctr"/>
+          <a:lstStyle/>
+          <a:p>
+            <a:pPr algn="ctr"/>
+          </a:p>
+        </p:txBody>
+      </p:sp>
+      <p:sp>
+        <p:nvSpPr>
+          <p:cNvPr id="12" name="Rectangle 11"/>
+          <p:cNvSpPr/>
+          <p:nvPr/>
+        </p:nvSpPr>
+        <p:spPr>
+          <a:xfrm>
+            <a:off x="9204682" y="1554480"/>
+            <a:ext cx="2115589" cy="36576"/>
+          </a:xfrm>
+          <a:prstGeom prst="rect">
+            <a:avLst/>
+          </a:prstGeom>
+          <a:solidFill>
+            <a:srgbClr val="D29922"/>
+          </a:solidFill>
+          <a:ln>
+            <a:noFill/>
+          </a:ln>
+          <a:effectLst/>
+        </p:spPr>
+        <p:style>
+          <a:lnRef idx="1">
+            <a:schemeClr val="accent1"/>
+          </a:lnRef>
+          <a:fillRef idx="3">
+            <a:schemeClr val="accent1"/>
+          </a:fillRef>
+          <a:effectRef idx="2">
+            <a:schemeClr val="accent1"/>
+          </a:effectRef>
+          <a:fontRef idx="minor">
+            <a:schemeClr val="lt1"/>
+          </a:fontRef>
+        </p:style>
+        <p:txBody>
+          <a:bodyPr rtlCol="0" anchor="ctr"/>
+          <a:lstStyle/>
+          <a:p>
+            <a:pPr algn="ctr"/>
+          </a:p>
+        </p:txBody>
+      </p:sp>
+      <p:sp>
+        <p:nvSpPr>
+          <p:cNvPr id="13" name="Oval 12"/>
+          <p:cNvSpPr/>
+          <p:nvPr/>
+        </p:nvSpPr>
+        <p:spPr>
+          <a:xfrm>
+            <a:off x="9250402" y="1719072"/>
+            <a:ext cx="347472" cy="347472"/>
+          </a:xfrm>
+          <a:prstGeom prst="ellipse">
+            <a:avLst/>
+          </a:prstGeom>
+          <a:solidFill>
+            <a:srgbClr val="D29922">
+              <a:alpha val="25000"/>
+            </a:srgbClr>
+          </a:solidFill>
+          <a:ln w="19050">
+            <a:solidFill>
+              <a:srgbClr val="D29922"/>
+            </a:solidFill>
+          </a:ln>
+          <a:effectLst/>
+        </p:spPr>
+        <p:style>
+          <a:lnRef idx="1">
+            <a:schemeClr val="accent1"/>
+          </a:lnRef>
+          <a:fillRef idx="3">
+            <a:schemeClr val="accent1"/>
+          </a:fillRef>
+          <a:effectRef idx="2">
+            <a:schemeClr val="accent1"/>
+          </a:effectRef>
+          <a:fontRef idx="minor">
+            <a:schemeClr val="lt1"/>
+          </a:fontRef>
+        </p:style>
+        <p:txBody>
+          <a:bodyPr rtlCol="0" anchor="ctr"/>
+          <a:lstStyle/>
+          <a:p>
+            <a:pPr algn="ctr"/>
+          </a:p>
+        </p:txBody>
+      </p:sp>
+      <p:sp>
+        <p:nvSpPr>
+          <p:cNvPr id="14" name="TextBox 13"/>
+          <p:cNvSpPr txBox="1"/>
+          <p:nvPr/>
+        </p:nvSpPr>
+        <p:spPr>
+          <a:xfrm>
+            <a:off x="9250402" y="1719072"/>
+            <a:ext cx="347472" cy="347472"/>
+          </a:xfrm>
+          <a:prstGeom prst="rect">
+            <a:avLst/>
+          </a:prstGeom>
+          <a:noFill/>
+        </p:spPr>
+        <p:txBody>
+          <a:bodyPr wrap="square" anchor="ctr" lIns="0" rIns="0">
+            <a:spAutoFit/>
+          </a:bodyPr>
+          <a:lstStyle/>
+          <a:p>
+            <a:pPr algn="ctr"/>
+            <a:r>
+              <a:rPr sz="1300" b="1" i="0">
+                <a:solidFill>
+                  <a:srgbClr val="D29922"/>
+                </a:solidFill>
+                <a:latin typeface="Segoe UI"/>
+                <a:ea typeface="Segoe UI"/>
+                <a:cs typeface="Segoe UI"/>
+              </a:rPr>
+              <a:t>1</a:t>
+            </a:r>
+          </a:p>
+        </p:txBody>
+      </p:sp>
+      <p:sp>
+        <p:nvSpPr>
+          <p:cNvPr id="15" name="TextBox 14"/>
+          <p:cNvSpPr txBox="1"/>
+          <p:nvPr/>
+        </p:nvSpPr>
+        <p:spPr>
+          <a:xfrm>
+            <a:off x="9689314" y="1719072"/>
+            <a:ext cx="1658389" cy="347472"/>
+          </a:xfrm>
+          <a:prstGeom prst="rect">
+            <a:avLst/>
+          </a:prstGeom>
+          <a:noFill/>
+        </p:spPr>
+        <p:txBody>
+          <a:bodyPr wrap="square" anchor="ctr" lIns="0" rIns="0">
+            <a:spAutoFit/>
+          </a:bodyPr>
+          <a:lstStyle/>
+          <a:p>
+            <a:pPr algn="l"/>
+            <a:r>
+              <a:rPr sz="1300" b="1" i="0">
+                <a:solidFill>
+                  <a:srgbClr val="D29922"/>
+                </a:solidFill>
+                <a:latin typeface="Segoe UI"/>
+                <a:ea typeface="Segoe UI"/>
+                <a:cs typeface="Segoe UI"/>
+              </a:rPr>
+              <a:t>GATE 1</a:t>
+            </a:r>
+          </a:p>
+        </p:txBody>
+      </p:sp>
+      <p:sp>
+        <p:nvSpPr>
+          <p:cNvPr id="16" name="TextBox 15"/>
+          <p:cNvSpPr txBox="1"/>
+          <p:nvPr/>
+        </p:nvSpPr>
+        <p:spPr>
+          <a:xfrm>
+            <a:off x="9250402" y="2139696"/>
+            <a:ext cx="2024149" cy="292608"/>
+          </a:xfrm>
+          <a:prstGeom prst="rect">
+            <a:avLst/>
+          </a:prstGeom>
+          <a:noFill/>
+        </p:spPr>
+        <p:txBody>
+          <a:bodyPr wrap="square" anchor="ctr" lIns="0" rIns="0">
+            <a:spAutoFit/>
+          </a:bodyPr>
+          <a:lstStyle/>
+          <a:p>
+            <a:pPr algn="l"/>
+            <a:r>
+              <a:rPr sz="1400" b="1" i="0">
+                <a:solidFill>
+                  <a:srgbClr val="E6EDF3"/>
+                </a:solidFill>
+                <a:latin typeface="Segoe UI"/>
+                <a:ea typeface="Segoe UI"/>
+                <a:cs typeface="Segoe UI"/>
+              </a:rPr>
+              <a:t>Approve the report</a:t>
+            </a:r>
+          </a:p>
+        </p:txBody>
+      </p:sp>
+      <p:sp>
+        <p:nvSpPr>
+          <p:cNvPr id="17" name="TextBox 16"/>
+          <p:cNvSpPr txBox="1"/>
+          <p:nvPr/>
+        </p:nvSpPr>
+        <p:spPr>
+          <a:xfrm>
+            <a:off x="9250402" y="2450591"/>
+            <a:ext cx="2024149" cy="414527"/>
+          </a:xfrm>
+          <a:prstGeom prst="rect">
+            <a:avLst/>
+          </a:prstGeom>
+          <a:noFill/>
+        </p:spPr>
+        <p:txBody>
+          <a:bodyPr wrap="square" anchor="t" lIns="0" rIns="0">
+            <a:spAutoFit/>
+          </a:bodyPr>
+          <a:lstStyle/>
+          <a:p>
+            <a:pPr algn="l"/>
+            <a:r>
+              <a:rPr sz="1200" b="0" i="0">
+                <a:solidFill>
+                  <a:srgbClr val="8B949E"/>
+                </a:solidFill>
+                <a:latin typeface="Segoe UI"/>
+                <a:ea typeface="Segoe UI"/>
+                <a:cs typeface="Segoe UI"/>
+              </a:rPr>
+              <a:t>Findings and predicted cost. No file has changed.</a:t>
+            </a:r>
+          </a:p>
+        </p:txBody>
+      </p:sp>
+      <p:sp>
+        <p:nvSpPr>
+          <p:cNvPr id="18" name="Rounded Rectangle 17"/>
+          <p:cNvSpPr/>
+          <p:nvPr/>
+        </p:nvSpPr>
+        <p:spPr>
+          <a:xfrm>
+            <a:off x="9094954" y="3221736"/>
+            <a:ext cx="2389909" cy="1402080"/>
+          </a:xfrm>
+          <a:prstGeom prst="roundRect">
+            <a:avLst>
+              <a:gd name="adj" fmla="val 7826"/>
+            </a:avLst>
+          </a:prstGeom>
+          <a:solidFill>
+            <a:srgbClr val="000000">
+              <a:alpha val="40000"/>
+            </a:srgbClr>
+          </a:solidFill>
+          <a:ln>
+            <a:noFill/>
+          </a:ln>
+          <a:effectLst/>
+        </p:spPr>
+        <p:style>
+          <a:lnRef idx="1">
+            <a:schemeClr val="accent1"/>
+          </a:lnRef>
+          <a:fillRef idx="3">
+            <a:schemeClr val="accent1"/>
+          </a:fillRef>
+          <a:effectRef idx="2">
+            <a:schemeClr val="accent1"/>
+          </a:effectRef>
+          <a:fontRef idx="minor">
+            <a:schemeClr val="lt1"/>
+          </a:fontRef>
+        </p:style>
+        <p:txBody>
+          <a:bodyPr rtlCol="0" anchor="ctr"/>
+          <a:lstStyle/>
+          <a:p>
+            <a:pPr algn="ctr"/>
+          </a:p>
+        </p:txBody>
+      </p:sp>
+      <p:sp>
+        <p:nvSpPr>
+          <p:cNvPr id="19" name="Rounded Rectangle 18"/>
+          <p:cNvSpPr/>
+          <p:nvPr/>
+        </p:nvSpPr>
+        <p:spPr>
+          <a:xfrm>
+            <a:off x="9067522" y="3185160"/>
+            <a:ext cx="2389909" cy="1402080"/>
+          </a:xfrm>
+          <a:prstGeom prst="roundRect">
+            <a:avLst>
+              <a:gd name="adj" fmla="val 7826"/>
+            </a:avLst>
+          </a:prstGeom>
+          <a:solidFill>
+            <a:srgbClr val="21262D"/>
+          </a:solidFill>
+          <a:ln w="6350">
+            <a:solidFill>
+              <a:srgbClr val="30363D"/>
+            </a:solidFill>
+          </a:ln>
+          <a:effectLst/>
+        </p:spPr>
+        <p:style>
+          <a:lnRef idx="1">
+            <a:schemeClr val="accent1"/>
+          </a:lnRef>
+          <a:fillRef idx="3">
+            <a:schemeClr val="accent1"/>
+          </a:fillRef>
+          <a:effectRef idx="2">
+            <a:schemeClr val="accent1"/>
+          </a:effectRef>
+          <a:fontRef idx="minor">
+            <a:schemeClr val="lt1"/>
+          </a:fontRef>
+        </p:style>
+        <p:txBody>
+          <a:bodyPr rtlCol="0" anchor="ctr"/>
+          <a:lstStyle/>
+          <a:p>
+            <a:pPr algn="ctr"/>
+          </a:p>
+        </p:txBody>
+      </p:sp>
+      <p:sp>
+        <p:nvSpPr>
+          <p:cNvPr id="20" name="Rectangle 19"/>
+          <p:cNvSpPr/>
+          <p:nvPr/>
+        </p:nvSpPr>
+        <p:spPr>
+          <a:xfrm>
+            <a:off x="9204682" y="3185160"/>
+            <a:ext cx="2115589" cy="36576"/>
+          </a:xfrm>
+          <a:prstGeom prst="rect">
+            <a:avLst/>
+          </a:prstGeom>
+          <a:solidFill>
+            <a:srgbClr val="D29922"/>
+          </a:solidFill>
+          <a:ln>
+            <a:noFill/>
+          </a:ln>
+          <a:effectLst/>
+        </p:spPr>
+        <p:style>
+          <a:lnRef idx="1">
+            <a:schemeClr val="accent1"/>
+          </a:lnRef>
+          <a:fillRef idx="3">
+            <a:schemeClr val="accent1"/>
+          </a:fillRef>
+          <a:effectRef idx="2">
+            <a:schemeClr val="accent1"/>
+          </a:effectRef>
+          <a:fontRef idx="minor">
+            <a:schemeClr val="lt1"/>
+          </a:fontRef>
+        </p:style>
+        <p:txBody>
+          <a:bodyPr rtlCol="0" anchor="ctr"/>
+          <a:lstStyle/>
+          <a:p>
+            <a:pPr algn="ctr"/>
+          </a:p>
+        </p:txBody>
+      </p:sp>
+      <p:sp>
+        <p:nvSpPr>
+          <p:cNvPr id="21" name="Oval 20"/>
+          <p:cNvSpPr/>
+          <p:nvPr/>
+        </p:nvSpPr>
+        <p:spPr>
+          <a:xfrm>
+            <a:off x="9250402" y="3349752"/>
+            <a:ext cx="347472" cy="347472"/>
+          </a:xfrm>
+          <a:prstGeom prst="ellipse">
+            <a:avLst/>
+          </a:prstGeom>
+          <a:solidFill>
+            <a:srgbClr val="D29922">
+              <a:alpha val="25000"/>
+            </a:srgbClr>
+          </a:solidFill>
+          <a:ln w="19050">
+            <a:solidFill>
+              <a:srgbClr val="D29922"/>
+            </a:solidFill>
+          </a:ln>
+          <a:effectLst/>
+        </p:spPr>
+        <p:style>
+          <a:lnRef idx="1">
+            <a:schemeClr val="accent1"/>
+          </a:lnRef>
+          <a:fillRef idx="3">
+            <a:schemeClr val="accent1"/>
+          </a:fillRef>
+          <a:effectRef idx="2">
+            <a:schemeClr val="accent1"/>
+          </a:effectRef>
+          <a:fontRef idx="minor">
+            <a:schemeClr val="lt1"/>
+          </a:fontRef>
+        </p:style>
+        <p:txBody>
+          <a:bodyPr rtlCol="0" anchor="ctr"/>
+          <a:lstStyle/>
+          <a:p>
+            <a:pPr algn="ctr"/>
+          </a:p>
+        </p:txBody>
+      </p:sp>
+      <p:sp>
+        <p:nvSpPr>
+          <p:cNvPr id="22" name="TextBox 21"/>
+          <p:cNvSpPr txBox="1"/>
+          <p:nvPr/>
+        </p:nvSpPr>
+        <p:spPr>
+          <a:xfrm>
+            <a:off x="9250402" y="3349752"/>
+            <a:ext cx="347472" cy="347472"/>
+          </a:xfrm>
+          <a:prstGeom prst="rect">
+            <a:avLst/>
+          </a:prstGeom>
+          <a:noFill/>
+        </p:spPr>
+        <p:txBody>
+          <a:bodyPr wrap="square" anchor="ctr" lIns="0" rIns="0">
+            <a:spAutoFit/>
+          </a:bodyPr>
+          <a:lstStyle/>
+          <a:p>
+            <a:pPr algn="ctr"/>
+            <a:r>
+              <a:rPr sz="1300" b="1" i="0">
+                <a:solidFill>
+                  <a:srgbClr val="D29922"/>
+                </a:solidFill>
+                <a:latin typeface="Segoe UI"/>
+                <a:ea typeface="Segoe UI"/>
+                <a:cs typeface="Segoe UI"/>
+              </a:rPr>
+              <a:t>2</a:t>
+            </a:r>
+          </a:p>
+        </p:txBody>
+      </p:sp>
+      <p:sp>
+        <p:nvSpPr>
+          <p:cNvPr id="23" name="TextBox 22"/>
+          <p:cNvSpPr txBox="1"/>
+          <p:nvPr/>
+        </p:nvSpPr>
+        <p:spPr>
+          <a:xfrm>
+            <a:off x="9689314" y="3349752"/>
+            <a:ext cx="1658389" cy="347472"/>
+          </a:xfrm>
+          <a:prstGeom prst="rect">
+            <a:avLst/>
+          </a:prstGeom>
+          <a:noFill/>
+        </p:spPr>
+        <p:txBody>
+          <a:bodyPr wrap="square" anchor="ctr" lIns="0" rIns="0">
+            <a:spAutoFit/>
+          </a:bodyPr>
+          <a:lstStyle/>
+          <a:p>
+            <a:pPr algn="l"/>
+            <a:r>
+              <a:rPr sz="1300" b="1" i="0">
+                <a:solidFill>
+                  <a:srgbClr val="D29922"/>
+                </a:solidFill>
+                <a:latin typeface="Segoe UI"/>
+                <a:ea typeface="Segoe UI"/>
+                <a:cs typeface="Segoe UI"/>
+              </a:rPr>
+              <a:t>GATE 2</a:t>
+            </a:r>
+          </a:p>
+        </p:txBody>
+      </p:sp>
+      <p:sp>
+        <p:nvSpPr>
+          <p:cNvPr id="24" name="TextBox 23"/>
+          <p:cNvSpPr txBox="1"/>
+          <p:nvPr/>
+        </p:nvSpPr>
+        <p:spPr>
+          <a:xfrm>
+            <a:off x="9250402" y="3770375"/>
+            <a:ext cx="2024149" cy="292608"/>
+          </a:xfrm>
+          <a:prstGeom prst="rect">
+            <a:avLst/>
+          </a:prstGeom>
+          <a:noFill/>
+        </p:spPr>
+        <p:txBody>
+          <a:bodyPr wrap="square" anchor="ctr" lIns="0" rIns="0">
+            <a:spAutoFit/>
+          </a:bodyPr>
+          <a:lstStyle/>
+          <a:p>
+            <a:pPr algn="l"/>
+            <a:r>
+              <a:rPr sz="1400" b="1" i="0">
+                <a:solidFill>
+                  <a:srgbClr val="E6EDF3"/>
+                </a:solidFill>
+                <a:latin typeface="Segoe UI"/>
+                <a:ea typeface="Segoe UI"/>
+                <a:cs typeface="Segoe UI"/>
+              </a:rPr>
+              <a:t>Merge the plan</a:t>
+            </a:r>
+          </a:p>
+        </p:txBody>
+      </p:sp>
+      <p:sp>
+        <p:nvSpPr>
+          <p:cNvPr id="25" name="TextBox 24"/>
+          <p:cNvSpPr txBox="1"/>
+          <p:nvPr/>
+        </p:nvSpPr>
+        <p:spPr>
+          <a:xfrm>
+            <a:off x="9250402" y="4081271"/>
+            <a:ext cx="2024149" cy="414527"/>
+          </a:xfrm>
+          <a:prstGeom prst="rect">
+            <a:avLst/>
+          </a:prstGeom>
+          <a:noFill/>
+        </p:spPr>
+        <p:txBody>
+          <a:bodyPr wrap="square" anchor="t" lIns="0" rIns="0">
+            <a:spAutoFit/>
+          </a:bodyPr>
+          <a:lstStyle/>
+          <a:p>
+            <a:pPr algn="l"/>
+            <a:r>
+              <a:rPr sz="1200" b="0" i="0">
+                <a:solidFill>
+                  <a:srgbClr val="8B949E"/>
+                </a:solidFill>
+                <a:latin typeface="Segoe UI"/>
+                <a:ea typeface="Segoe UI"/>
+                <a:cs typeface="Segoe UI"/>
+              </a:rPr>
+              <a:t>Only Markdown and evidence reach main.</a:t>
+            </a:r>
+          </a:p>
+        </p:txBody>
+      </p:sp>
+      <p:sp>
+        <p:nvSpPr>
+          <p:cNvPr id="26" name="Rounded Rectangle 25"/>
+          <p:cNvSpPr/>
+          <p:nvPr/>
+        </p:nvSpPr>
+        <p:spPr>
+          <a:xfrm>
+            <a:off x="9094954" y="4852416"/>
+            <a:ext cx="2389909" cy="1402080"/>
+          </a:xfrm>
+          <a:prstGeom prst="roundRect">
+            <a:avLst>
+              <a:gd name="adj" fmla="val 7826"/>
+            </a:avLst>
+          </a:prstGeom>
+          <a:solidFill>
+            <a:srgbClr val="000000">
+              <a:alpha val="40000"/>
+            </a:srgbClr>
+          </a:solidFill>
+          <a:ln>
+            <a:noFill/>
+          </a:ln>
+          <a:effectLst/>
+        </p:spPr>
+        <p:style>
+          <a:lnRef idx="1">
+            <a:schemeClr val="accent1"/>
+          </a:lnRef>
+          <a:fillRef idx="3">
+            <a:schemeClr val="accent1"/>
+          </a:fillRef>
+          <a:effectRef idx="2">
+            <a:schemeClr val="accent1"/>
+          </a:effectRef>
+          <a:fontRef idx="minor">
+            <a:schemeClr val="lt1"/>
+          </a:fontRef>
+        </p:style>
+        <p:txBody>
+          <a:bodyPr rtlCol="0" anchor="ctr"/>
+          <a:lstStyle/>
+          <a:p>
+            <a:pPr algn="ctr"/>
+          </a:p>
+        </p:txBody>
+      </p:sp>
+      <p:sp>
+        <p:nvSpPr>
+          <p:cNvPr id="27" name="Rounded Rectangle 26"/>
+          <p:cNvSpPr/>
+          <p:nvPr/>
+        </p:nvSpPr>
+        <p:spPr>
+          <a:xfrm>
+            <a:off x="9067522" y="4815840"/>
+            <a:ext cx="2389909" cy="1402080"/>
+          </a:xfrm>
+          <a:prstGeom prst="roundRect">
+            <a:avLst>
+              <a:gd name="adj" fmla="val 7826"/>
+            </a:avLst>
+          </a:prstGeom>
+          <a:solidFill>
+            <a:srgbClr val="21262D"/>
+          </a:solidFill>
+          <a:ln w="6350">
+            <a:solidFill>
+              <a:srgbClr val="30363D"/>
+            </a:solidFill>
+          </a:ln>
+          <a:effectLst/>
+        </p:spPr>
+        <p:style>
+          <a:lnRef idx="1">
+            <a:schemeClr val="accent1"/>
+          </a:lnRef>
+          <a:fillRef idx="3">
+            <a:schemeClr val="accent1"/>
+          </a:fillRef>
+          <a:effectRef idx="2">
+            <a:schemeClr val="accent1"/>
+          </a:effectRef>
+          <a:fontRef idx="minor">
+            <a:schemeClr val="lt1"/>
+          </a:fontRef>
+        </p:style>
+        <p:txBody>
+          <a:bodyPr rtlCol="0" anchor="ctr"/>
+          <a:lstStyle/>
+          <a:p>
+            <a:pPr algn="ctr"/>
+          </a:p>
+        </p:txBody>
+      </p:sp>
+      <p:sp>
+        <p:nvSpPr>
+          <p:cNvPr id="28" name="Rectangle 27"/>
+          <p:cNvSpPr/>
+          <p:nvPr/>
+        </p:nvSpPr>
+        <p:spPr>
+          <a:xfrm>
+            <a:off x="9204682" y="4815840"/>
+            <a:ext cx="2115589" cy="36576"/>
+          </a:xfrm>
+          <a:prstGeom prst="rect">
+            <a:avLst/>
+          </a:prstGeom>
+          <a:solidFill>
+            <a:srgbClr val="D29922"/>
+          </a:solidFill>
+          <a:ln>
+            <a:noFill/>
+          </a:ln>
+          <a:effectLst/>
+        </p:spPr>
+        <p:style>
+          <a:lnRef idx="1">
+            <a:schemeClr val="accent1"/>
+          </a:lnRef>
+          <a:fillRef idx="3">
+            <a:schemeClr val="accent1"/>
+          </a:fillRef>
+          <a:effectRef idx="2">
+            <a:schemeClr val="accent1"/>
+          </a:effectRef>
+          <a:fontRef idx="minor">
+            <a:schemeClr val="lt1"/>
+          </a:fontRef>
+        </p:style>
+        <p:txBody>
+          <a:bodyPr rtlCol="0" anchor="ctr"/>
+          <a:lstStyle/>
+          <a:p>
+            <a:pPr algn="ctr"/>
+          </a:p>
+        </p:txBody>
+      </p:sp>
+      <p:sp>
+        <p:nvSpPr>
+          <p:cNvPr id="29" name="Oval 28"/>
+          <p:cNvSpPr/>
+          <p:nvPr/>
+        </p:nvSpPr>
+        <p:spPr>
+          <a:xfrm>
+            <a:off x="9250402" y="4980432"/>
+            <a:ext cx="347472" cy="347472"/>
+          </a:xfrm>
+          <a:prstGeom prst="ellipse">
+            <a:avLst/>
+          </a:prstGeom>
+          <a:solidFill>
+            <a:srgbClr val="D29922">
+              <a:alpha val="25000"/>
+            </a:srgbClr>
+          </a:solidFill>
+          <a:ln w="19050">
+            <a:solidFill>
+              <a:srgbClr val="D29922"/>
+            </a:solidFill>
+          </a:ln>
+          <a:effectLst/>
+        </p:spPr>
+        <p:style>
+          <a:lnRef idx="1">
+            <a:schemeClr val="accent1"/>
+          </a:lnRef>
+          <a:fillRef idx="3">
+            <a:schemeClr val="accent1"/>
+          </a:fillRef>
+          <a:effectRef idx="2">
+            <a:schemeClr val="accent1"/>
+          </a:effectRef>
+          <a:fontRef idx="minor">
+            <a:schemeClr val="lt1"/>
+          </a:fontRef>
+        </p:style>
+        <p:txBody>
+          <a:bodyPr rtlCol="0" anchor="ctr"/>
+          <a:lstStyle/>
+          <a:p>
+            <a:pPr algn="ctr"/>
+          </a:p>
+        </p:txBody>
+      </p:sp>
+      <p:sp>
+        <p:nvSpPr>
+          <p:cNvPr id="30" name="TextBox 29"/>
+          <p:cNvSpPr txBox="1"/>
+          <p:nvPr/>
+        </p:nvSpPr>
+        <p:spPr>
+          <a:xfrm>
+            <a:off x="9250402" y="4980432"/>
+            <a:ext cx="347472" cy="347472"/>
+          </a:xfrm>
+          <a:prstGeom prst="rect">
+            <a:avLst/>
+          </a:prstGeom>
+          <a:noFill/>
+        </p:spPr>
+        <p:txBody>
+          <a:bodyPr wrap="square" anchor="ctr" lIns="0" rIns="0">
+            <a:spAutoFit/>
+          </a:bodyPr>
+          <a:lstStyle/>
+          <a:p>
+            <a:pPr algn="ctr"/>
+            <a:r>
+              <a:rPr sz="1300" b="1" i="0">
+                <a:solidFill>
+                  <a:srgbClr val="D29922"/>
+                </a:solidFill>
+                <a:latin typeface="Segoe UI"/>
+                <a:ea typeface="Segoe UI"/>
+                <a:cs typeface="Segoe UI"/>
+              </a:rPr>
+              <a:t>3</a:t>
+            </a:r>
+          </a:p>
+        </p:txBody>
+      </p:sp>
+      <p:sp>
+        <p:nvSpPr>
+          <p:cNvPr id="31" name="TextBox 30"/>
+          <p:cNvSpPr txBox="1"/>
+          <p:nvPr/>
+        </p:nvSpPr>
+        <p:spPr>
+          <a:xfrm>
+            <a:off x="9689314" y="4980432"/>
+            <a:ext cx="1658389" cy="347472"/>
+          </a:xfrm>
+          <a:prstGeom prst="rect">
+            <a:avLst/>
+          </a:prstGeom>
+          <a:noFill/>
+        </p:spPr>
+        <p:txBody>
+          <a:bodyPr wrap="square" anchor="ctr" lIns="0" rIns="0">
+            <a:spAutoFit/>
+          </a:bodyPr>
+          <a:lstStyle/>
+          <a:p>
+            <a:pPr algn="l"/>
+            <a:r>
+              <a:rPr sz="1300" b="1" i="0">
+                <a:solidFill>
+                  <a:srgbClr val="D29922"/>
+                </a:solidFill>
+                <a:latin typeface="Segoe UI"/>
+                <a:ea typeface="Segoe UI"/>
+                <a:cs typeface="Segoe UI"/>
+              </a:rPr>
+              <a:t>GATE 3</a:t>
+            </a:r>
+          </a:p>
+        </p:txBody>
+      </p:sp>
+      <p:sp>
+        <p:nvSpPr>
+          <p:cNvPr id="32" name="TextBox 31"/>
+          <p:cNvSpPr txBox="1"/>
+          <p:nvPr/>
+        </p:nvSpPr>
+        <p:spPr>
+          <a:xfrm>
+            <a:off x="9250402" y="5401056"/>
+            <a:ext cx="2024149" cy="292608"/>
+          </a:xfrm>
+          <a:prstGeom prst="rect">
+            <a:avLst/>
+          </a:prstGeom>
+          <a:noFill/>
+        </p:spPr>
+        <p:txBody>
+          <a:bodyPr wrap="square" anchor="ctr" lIns="0" rIns="0">
+            <a:spAutoFit/>
+          </a:bodyPr>
+          <a:lstStyle/>
+          <a:p>
+            <a:pPr algn="l"/>
+            <a:r>
+              <a:rPr sz="1400" b="1" i="0">
+                <a:solidFill>
+                  <a:srgbClr val="E6EDF3"/>
+                </a:solidFill>
+                <a:latin typeface="Segoe UI"/>
+                <a:ea typeface="Segoe UI"/>
+                <a:cs typeface="Segoe UI"/>
+              </a:rPr>
+              <a:t>Approve, don’t merge</a:t>
+            </a:r>
+          </a:p>
+        </p:txBody>
+      </p:sp>
+      <p:sp>
+        <p:nvSpPr>
+          <p:cNvPr id="33" name="TextBox 32"/>
+          <p:cNvSpPr txBox="1"/>
+          <p:nvPr/>
+        </p:nvSpPr>
+        <p:spPr>
+          <a:xfrm>
+            <a:off x="9250402" y="5711951"/>
+            <a:ext cx="2024149" cy="414527"/>
+          </a:xfrm>
+          <a:prstGeom prst="rect">
+            <a:avLst/>
+          </a:prstGeom>
+          <a:noFill/>
+        </p:spPr>
+        <p:txBody>
+          <a:bodyPr wrap="square" anchor="t" lIns="0" rIns="0">
+            <a:spAutoFit/>
+          </a:bodyPr>
+          <a:lstStyle/>
+          <a:p>
+            <a:pPr algn="l"/>
+            <a:r>
+              <a:rPr sz="1200" b="0" i="0">
+                <a:solidFill>
+                  <a:srgbClr val="8B949E"/>
+                </a:solidFill>
+                <a:latin typeface="Segoe UI"/>
+                <a:ea typeface="Segoe UI"/>
+                <a:cs typeface="Segoe UI"/>
+              </a:rPr>
+              <a:t>Review only; main stays on Java 8.</a:t>
+            </a:r>
+          </a:p>
+        </p:txBody>
+      </p:sp>
+    </p:spTree>
+  </p:cSld>
+  <p:clrMapOvr>
+    <a:masterClrMapping/>
+  </p:clrMapOvr>
+</p:sld>
+</file>
+
+<file path=ppt/slides/slide11.xml><?xml version="1.0" encoding="utf-8"?>
+<p:sld xmlns:a="http://schemas.openxmlformats.org/drawingml/2006/main" xmlns:p="http://schemas.openxmlformats.org/presentationml/2006/main" xmlns:r="http://schemas.openxmlformats.org/officeDocument/2006/relationships">
+  <p:cSld>
+    <p:bg>
+      <p:bgPr>
+        <a:solidFill>
+          <a:srgbClr val="0D1117"/>
+        </a:solidFill>
+        <a:effectLst/>
+      </p:bgPr>
+    </p:bg>
+    <p:spTree>
+      <p:nvGrpSpPr>
+        <p:cNvPr id="1" name=""/>
+        <p:cNvGrpSpPr/>
+        <p:nvPr/>
+      </p:nvGrpSpPr>
+      <p:grpSpPr/>
+      <p:sp>
+        <p:nvSpPr>
+          <p:cNvPr id="2" name="Rectangle 1"/>
+          <p:cNvSpPr/>
+          <p:nvPr/>
+        </p:nvSpPr>
+        <p:spPr>
+          <a:xfrm>
+            <a:off x="0" y="0"/>
+            <a:ext cx="12191695" cy="36576"/>
+          </a:xfrm>
+          <a:prstGeom prst="rect">
+            <a:avLst/>
+          </a:prstGeom>
+          <a:solidFill>
+            <a:srgbClr val="238636"/>
+          </a:solidFill>
+          <a:ln>
+            <a:noFill/>
+          </a:ln>
+          <a:effectLst/>
+        </p:spPr>
+        <p:style>
+          <a:lnRef idx="1">
+            <a:schemeClr val="accent1"/>
+          </a:lnRef>
+          <a:fillRef idx="3">
+            <a:schemeClr val="accent1"/>
+          </a:fillRef>
+          <a:effectRef idx="2">
+            <a:schemeClr val="accent1"/>
+          </a:effectRef>
+          <a:fontRef idx="minor">
+            <a:schemeClr val="lt1"/>
+          </a:fontRef>
+        </p:style>
+        <p:txBody>
+          <a:bodyPr rtlCol="0" anchor="ctr"/>
+          <a:lstStyle/>
+          <a:p>
+            <a:pPr algn="ctr"/>
+          </a:p>
+        </p:txBody>
+      </p:sp>
+      <p:sp>
+        <p:nvSpPr>
+          <p:cNvPr id="3" name="TextBox 2"/>
+          <p:cNvSpPr txBox="1"/>
+          <p:nvPr/>
+        </p:nvSpPr>
+        <p:spPr>
+          <a:xfrm>
+            <a:off x="731520" y="6400800"/>
+            <a:ext cx="7315200" cy="320040"/>
+          </a:xfrm>
+          <a:prstGeom prst="rect">
+            <a:avLst/>
+          </a:prstGeom>
+          <a:noFill/>
+        </p:spPr>
+        <p:txBody>
+          <a:bodyPr wrap="square" anchor="ctr">
+            <a:spAutoFit/>
+          </a:bodyPr>
+          <a:lstStyle/>
+          <a:p>
+            <a:pPr algn="l"/>
+            <a:r>
+              <a:rPr sz="1000" b="0" i="0">
+                <a:solidFill>
+                  <a:srgbClr val="484F58"/>
+                </a:solidFill>
+                <a:latin typeface="Segoe UI"/>
+                <a:ea typeface="Segoe UI"/>
+                <a:cs typeface="Segoe UI"/>
+              </a:rPr>
+              <a:t>Innovate 2026  ·  ADO/GitHub with Microsoft</a:t>
+            </a:r>
+          </a:p>
+        </p:txBody>
+      </p:sp>
+      <p:sp>
+        <p:nvSpPr>
+          <p:cNvPr id="4" name="Text 2"/>
+          <p:cNvSpPr txBox="1"/>
+          <p:nvPr/>
+        </p:nvSpPr>
+        <p:spPr>
+          <a:xfrm>
+            <a:off x="11155680" y="6446520"/>
+            <a:ext cx="822960" cy="274320"/>
+          </a:xfrm>
+          <a:prstGeom prst="rect">
+            <a:avLst/>
+          </a:prstGeom>
+          <a:noFill/>
+        </p:spPr>
+        <p:txBody>
+          <a:bodyPr wrap="square" anchor="ctr">
+            <a:spAutoFit/>
+          </a:bodyPr>
+          <a:lstStyle/>
+          <a:p>
+            <a:pPr algn="r"/>
+            <a:r>
+              <a:rPr sz="1000" b="0" i="0">
+                <a:solidFill>
+                  <a:srgbClr val="484F58"/>
+                </a:solidFill>
+                <a:latin typeface="Segoe UI"/>
+                <a:ea typeface="Segoe UI"/>
+                <a:cs typeface="Segoe UI"/>
+              </a:rPr>
+              <a:t>8 / 11</a:t>
+            </a:r>
+          </a:p>
+        </p:txBody>
+      </p:sp>
+      <p:sp>
+        <p:nvSpPr>
+          <p:cNvPr id="5" name="TextBox 4"/>
+          <p:cNvSpPr txBox="1"/>
+          <p:nvPr/>
+        </p:nvSpPr>
+        <p:spPr>
+          <a:xfrm>
+            <a:off x="731520" y="320040"/>
+            <a:ext cx="10058400" cy="640080"/>
+          </a:xfrm>
+          <a:prstGeom prst="rect">
+            <a:avLst/>
+          </a:prstGeom>
+          <a:noFill/>
+        </p:spPr>
+        <p:txBody>
+          <a:bodyPr wrap="square" anchor="ctr">
+            <a:spAutoFit/>
+          </a:bodyPr>
+          <a:lstStyle/>
+          <a:p>
+            <a:pPr algn="l"/>
+            <a:r>
+              <a:rPr sz="3800" b="1" i="0">
+                <a:solidFill>
+                  <a:srgbClr val="E6EDF3"/>
+                </a:solidFill>
+                <a:latin typeface="Segoe UI"/>
+                <a:ea typeface="Segoe UI"/>
+                <a:cs typeface="Segoe UI"/>
+              </a:rPr>
+              <a:t>One Canvas: Buttons, Not Scripts</a:t>
+            </a:r>
+          </a:p>
+        </p:txBody>
+      </p:sp>
+      <p:sp>
+        <p:nvSpPr>
+          <p:cNvPr id="6" name="TextBox 5"/>
+          <p:cNvSpPr txBox="1"/>
+          <p:nvPr/>
+        </p:nvSpPr>
+        <p:spPr>
+          <a:xfrm>
+            <a:off x="731520" y="914400"/>
+            <a:ext cx="10515600" cy="365760"/>
+          </a:xfrm>
+          <a:prstGeom prst="rect">
+            <a:avLst/>
+          </a:prstGeom>
+          <a:noFill/>
+        </p:spPr>
+        <p:txBody>
+          <a:bodyPr wrap="square" anchor="ctr">
+            <a:spAutoFit/>
+          </a:bodyPr>
+          <a:lstStyle/>
+          <a:p>
+            <a:pPr algn="l"/>
+            <a:r>
+              <a:rPr sz="1800" b="0" i="1">
+                <a:solidFill>
+                  <a:srgbClr val="8B949E"/>
+                </a:solidFill>
+                <a:latin typeface="Segoe UI"/>
+                <a:ea typeface="Segoe UI"/>
+                <a:cs typeface="Segoe UI"/>
+              </a:rPr>
+              <a:t>The Software Factory canvas drives the run and shows live progress and cost</a:t>
+            </a:r>
+          </a:p>
+        </p:txBody>
+      </p:sp>
+      <p:sp>
+        <p:nvSpPr>
+          <p:cNvPr id="7" name="Rounded Rectangle 6"/>
+          <p:cNvSpPr/>
+          <p:nvPr/>
+        </p:nvSpPr>
+        <p:spPr>
+          <a:xfrm>
+            <a:off x="758952" y="1591056"/>
+            <a:ext cx="5225796" cy="2011680"/>
+          </a:xfrm>
+          <a:prstGeom prst="roundRect">
+            <a:avLst>
+              <a:gd name="adj" fmla="val 5454"/>
+            </a:avLst>
+          </a:prstGeom>
+          <a:solidFill>
+            <a:srgbClr val="000000">
+              <a:alpha val="40000"/>
+            </a:srgbClr>
+          </a:solidFill>
+          <a:ln>
+            <a:noFill/>
+          </a:ln>
+          <a:effectLst/>
+        </p:spPr>
+        <p:style>
+          <a:lnRef idx="1">
+            <a:schemeClr val="accent1"/>
+          </a:lnRef>
+          <a:fillRef idx="3">
+            <a:schemeClr val="accent1"/>
+          </a:fillRef>
+          <a:effectRef idx="2">
+            <a:schemeClr val="accent1"/>
+          </a:effectRef>
+          <a:fontRef idx="minor">
+            <a:schemeClr val="lt1"/>
+          </a:fontRef>
+        </p:style>
+        <p:txBody>
+          <a:bodyPr rtlCol="0" anchor="ctr"/>
+          <a:lstStyle/>
+          <a:p>
+            <a:pPr algn="ctr"/>
+          </a:p>
+        </p:txBody>
+      </p:sp>
+      <p:sp>
+        <p:nvSpPr>
+          <p:cNvPr id="8" name="Rounded Rectangle 7"/>
+          <p:cNvSpPr/>
+          <p:nvPr/>
+        </p:nvSpPr>
+        <p:spPr>
+          <a:xfrm>
+            <a:off x="731520" y="1554480"/>
+            <a:ext cx="5225796" cy="2011680"/>
+          </a:xfrm>
+          <a:prstGeom prst="roundRect">
+            <a:avLst>
+              <a:gd name="adj" fmla="val 5454"/>
+            </a:avLst>
+          </a:prstGeom>
+          <a:solidFill>
+            <a:srgbClr val="21262D"/>
+          </a:solidFill>
+          <a:ln w="6350">
+            <a:solidFill>
+              <a:srgbClr val="30363D"/>
+            </a:solidFill>
+          </a:ln>
+          <a:effectLst/>
+        </p:spPr>
+        <p:style>
+          <a:lnRef idx="1">
+            <a:schemeClr val="accent1"/>
+          </a:lnRef>
+          <a:fillRef idx="3">
+            <a:schemeClr val="accent1"/>
+          </a:fillRef>
+          <a:effectRef idx="2">
+            <a:schemeClr val="accent1"/>
+          </a:effectRef>
+          <a:fontRef idx="minor">
+            <a:schemeClr val="lt1"/>
+          </a:fontRef>
+        </p:style>
+        <p:txBody>
+          <a:bodyPr rtlCol="0" anchor="ctr"/>
+          <a:lstStyle/>
+          <a:p>
+            <a:pPr algn="ctr"/>
+          </a:p>
+        </p:txBody>
+      </p:sp>
+      <p:sp>
+        <p:nvSpPr>
+          <p:cNvPr id="9" name="Rectangle 8"/>
+          <p:cNvSpPr/>
+          <p:nvPr/>
+        </p:nvSpPr>
+        <p:spPr>
+          <a:xfrm>
+            <a:off x="868680" y="1554480"/>
+            <a:ext cx="4951476" cy="36576"/>
+          </a:xfrm>
+          <a:prstGeom prst="rect">
+            <a:avLst/>
+          </a:prstGeom>
+          <a:solidFill>
+            <a:srgbClr val="3FB950"/>
+          </a:solidFill>
+          <a:ln>
+            <a:noFill/>
+          </a:ln>
+          <a:effectLst/>
+        </p:spPr>
+        <p:style>
+          <a:lnRef idx="1">
+            <a:schemeClr val="accent1"/>
+          </a:lnRef>
+          <a:fillRef idx="3">
+            <a:schemeClr val="accent1"/>
+          </a:fillRef>
+          <a:effectRef idx="2">
+            <a:schemeClr val="accent1"/>
+          </a:effectRef>
+          <a:fontRef idx="minor">
+            <a:schemeClr val="lt1"/>
+          </a:fontRef>
+        </p:style>
+        <p:txBody>
+          <a:bodyPr rtlCol="0" anchor="ctr"/>
+          <a:lstStyle/>
+          <a:p>
+            <a:pPr algn="ctr"/>
+          </a:p>
+        </p:txBody>
+      </p:sp>
+      <p:sp>
+        <p:nvSpPr>
+          <p:cNvPr id="10" name="TextBox 9"/>
+          <p:cNvSpPr txBox="1"/>
+          <p:nvPr/>
+        </p:nvSpPr>
+        <p:spPr>
+          <a:xfrm>
+            <a:off x="1005840" y="1737360"/>
+            <a:ext cx="4677156" cy="457200"/>
+          </a:xfrm>
+          <a:prstGeom prst="rect">
+            <a:avLst/>
+          </a:prstGeom>
+          <a:noFill/>
+        </p:spPr>
+        <p:txBody>
+          <a:bodyPr wrap="square" anchor="ctr" lIns="0" rIns="0">
+            <a:spAutoFit/>
+          </a:bodyPr>
+          <a:lstStyle/>
+          <a:p>
+            <a:pPr algn="l"/>
+            <a:r>
+              <a:rPr sz="1800" b="1" i="0">
+                <a:solidFill>
+                  <a:srgbClr val="3FB950"/>
+                </a:solidFill>
+                <a:latin typeface="Segoe UI"/>
+                <a:ea typeface="Segoe UI"/>
+                <a:cs typeface="Segoe UI"/>
+              </a:rPr>
+              <a:t>Direct clicks — never through AI</a:t>
+            </a:r>
+          </a:p>
+        </p:txBody>
+      </p:sp>
+      <p:sp>
+        <p:nvSpPr>
+          <p:cNvPr id="11" name="TextBox 10"/>
+          <p:cNvSpPr txBox="1"/>
+          <p:nvPr/>
+        </p:nvSpPr>
+        <p:spPr>
+          <a:xfrm>
+            <a:off x="1005840" y="2240280"/>
+            <a:ext cx="4677156" cy="1188720"/>
+          </a:xfrm>
+          <a:prstGeom prst="rect">
+            <a:avLst/>
+          </a:prstGeom>
+          <a:noFill/>
+        </p:spPr>
+        <p:txBody>
+          <a:bodyPr wrap="square" anchor="t" lIns="0" rIns="0">
+            <a:spAutoFit/>
+          </a:bodyPr>
+          <a:lstStyle/>
+          <a:p>
+            <a:pPr algn="l">
+              <a:lnSpc>
+                <a:spcPct val="125000"/>
+              </a:lnSpc>
+            </a:pPr>
+            <a:r>
+              <a:rPr sz="1400" b="1" i="0">
+                <a:solidFill>
+                  <a:srgbClr val="3FB950"/>
+                </a:solidFill>
+                <a:latin typeface="Segoe UI"/>
+                <a:ea typeface="Segoe UI"/>
+                <a:cs typeface="Segoe UI"/>
+              </a:rPr>
+              <a:t>✓  </a:t>
+            </a:r>
+            <a:r>
+              <a:rPr sz="1400" b="0" i="0">
+                <a:solidFill>
+                  <a:srgbClr val="E6EDF3"/>
+                </a:solidFill>
+                <a:latin typeface="Segoe UI"/>
+                <a:ea typeface="Segoe UI"/>
+                <a:cs typeface="Segoe UI"/>
+              </a:rPr>
+              <a:t>Save the Copilot token</a:t>
+            </a:r>
+          </a:p>
+          <a:p>
+            <a:pPr algn="l">
+              <a:lnSpc>
+                <a:spcPct val="125000"/>
+              </a:lnSpc>
+            </a:pPr>
+            <a:r>
+              <a:rPr sz="1400" b="1" i="0">
+                <a:solidFill>
+                  <a:srgbClr val="3FB950"/>
+                </a:solidFill>
+                <a:latin typeface="Segoe UI"/>
+                <a:ea typeface="Segoe UI"/>
+                <a:cs typeface="Segoe UI"/>
+              </a:rPr>
+              <a:t>✓  </a:t>
+            </a:r>
+            <a:r>
+              <a:rPr sz="1400" b="0" i="0">
+                <a:solidFill>
+                  <a:srgbClr val="E6EDF3"/>
+                </a:solidFill>
+                <a:latin typeface="Segoe UI"/>
+                <a:ea typeface="Segoe UI"/>
+                <a:cs typeface="Segoe UI"/>
+              </a:rPr>
+              <a:t>Start the /modernize request</a:t>
+            </a:r>
+          </a:p>
+          <a:p>
+            <a:pPr algn="l">
+              <a:lnSpc>
+                <a:spcPct val="125000"/>
+              </a:lnSpc>
+            </a:pPr>
+            <a:r>
+              <a:rPr sz="1400" b="1" i="0">
+                <a:solidFill>
+                  <a:srgbClr val="3FB950"/>
+                </a:solidFill>
+                <a:latin typeface="Segoe UI"/>
+                <a:ea typeface="Segoe UI"/>
+                <a:cs typeface="Segoe UI"/>
+              </a:rPr>
+              <a:t>✓  </a:t>
+            </a:r>
+            <a:r>
+              <a:rPr sz="1400" b="0" i="0">
+                <a:solidFill>
+                  <a:srgbClr val="E6EDF3"/>
+                </a:solidFill>
+                <a:latin typeface="Segoe UI"/>
+                <a:ea typeface="Segoe UI"/>
+                <a:cs typeface="Segoe UI"/>
+              </a:rPr>
+              <a:t>Approve gate 1, merge the plan (gate 2)</a:t>
+            </a:r>
+          </a:p>
+          <a:p>
+            <a:pPr algn="l">
+              <a:lnSpc>
+                <a:spcPct val="125000"/>
+              </a:lnSpc>
+            </a:pPr>
+            <a:r>
+              <a:rPr sz="1400" b="1" i="0">
+                <a:solidFill>
+                  <a:srgbClr val="3FB950"/>
+                </a:solidFill>
+                <a:latin typeface="Segoe UI"/>
+                <a:ea typeface="Segoe UI"/>
+                <a:cs typeface="Segoe UI"/>
+              </a:rPr>
+              <a:t>✓  </a:t>
+            </a:r>
+            <a:r>
+              <a:rPr sz="1400" b="0" i="0">
+                <a:solidFill>
+                  <a:srgbClr val="E6EDF3"/>
+                </a:solidFill>
+                <a:latin typeface="Segoe UI"/>
+                <a:ea typeface="Segoe UI"/>
+                <a:cs typeface="Segoe UI"/>
+              </a:rPr>
+              <a:t>Approve the Implementation PR (gate 3)</a:t>
+            </a:r>
+          </a:p>
+        </p:txBody>
+      </p:sp>
+      <p:sp>
+        <p:nvSpPr>
+          <p:cNvPr id="12" name="Rounded Rectangle 11"/>
+          <p:cNvSpPr/>
+          <p:nvPr/>
+        </p:nvSpPr>
+        <p:spPr>
+          <a:xfrm>
+            <a:off x="6259068" y="1591056"/>
+            <a:ext cx="5225796" cy="2011680"/>
+          </a:xfrm>
+          <a:prstGeom prst="roundRect">
+            <a:avLst>
+              <a:gd name="adj" fmla="val 5454"/>
+            </a:avLst>
+          </a:prstGeom>
+          <a:solidFill>
+            <a:srgbClr val="000000">
+              <a:alpha val="40000"/>
+            </a:srgbClr>
+          </a:solidFill>
+          <a:ln>
+            <a:noFill/>
+          </a:ln>
+          <a:effectLst/>
+        </p:spPr>
+        <p:style>
+          <a:lnRef idx="1">
+            <a:schemeClr val="accent1"/>
+          </a:lnRef>
+          <a:fillRef idx="3">
+            <a:schemeClr val="accent1"/>
+          </a:fillRef>
+          <a:effectRef idx="2">
+            <a:schemeClr val="accent1"/>
+          </a:effectRef>
+          <a:fontRef idx="minor">
+            <a:schemeClr val="lt1"/>
+          </a:fontRef>
+        </p:style>
+        <p:txBody>
+          <a:bodyPr rtlCol="0" anchor="ctr"/>
+          <a:lstStyle/>
+          <a:p>
+            <a:pPr algn="ctr"/>
+          </a:p>
+        </p:txBody>
+      </p:sp>
+      <p:sp>
+        <p:nvSpPr>
+          <p:cNvPr id="13" name="Rounded Rectangle 12"/>
+          <p:cNvSpPr/>
+          <p:nvPr/>
+        </p:nvSpPr>
+        <p:spPr>
+          <a:xfrm>
+            <a:off x="6231636" y="1554480"/>
+            <a:ext cx="5225796" cy="2011680"/>
+          </a:xfrm>
+          <a:prstGeom prst="roundRect">
+            <a:avLst>
+              <a:gd name="adj" fmla="val 5454"/>
+            </a:avLst>
+          </a:prstGeom>
+          <a:solidFill>
+            <a:srgbClr val="21262D"/>
+          </a:solidFill>
+          <a:ln w="6350">
+            <a:solidFill>
+              <a:srgbClr val="30363D"/>
+            </a:solidFill>
+          </a:ln>
+          <a:effectLst/>
+        </p:spPr>
+        <p:style>
+          <a:lnRef idx="1">
+            <a:schemeClr val="accent1"/>
+          </a:lnRef>
+          <a:fillRef idx="3">
+            <a:schemeClr val="accent1"/>
+          </a:fillRef>
+          <a:effectRef idx="2">
+            <a:schemeClr val="accent1"/>
+          </a:effectRef>
+          <a:fontRef idx="minor">
+            <a:schemeClr val="lt1"/>
+          </a:fontRef>
+        </p:style>
+        <p:txBody>
+          <a:bodyPr rtlCol="0" anchor="ctr"/>
+          <a:lstStyle/>
+          <a:p>
+            <a:pPr algn="ctr"/>
+          </a:p>
+        </p:txBody>
+      </p:sp>
+      <p:sp>
+        <p:nvSpPr>
+          <p:cNvPr id="14" name="Rectangle 13"/>
+          <p:cNvSpPr/>
+          <p:nvPr/>
+        </p:nvSpPr>
+        <p:spPr>
+          <a:xfrm>
+            <a:off x="6368796" y="1554480"/>
+            <a:ext cx="4951476" cy="36576"/>
+          </a:xfrm>
+          <a:prstGeom prst="rect">
+            <a:avLst/>
+          </a:prstGeom>
+          <a:solidFill>
+            <a:srgbClr val="A371F7"/>
+          </a:solidFill>
+          <a:ln>
+            <a:noFill/>
+          </a:ln>
+          <a:effectLst/>
+        </p:spPr>
+        <p:style>
+          <a:lnRef idx="1">
+            <a:schemeClr val="accent1"/>
+          </a:lnRef>
+          <a:fillRef idx="3">
+            <a:schemeClr val="accent1"/>
+          </a:fillRef>
+          <a:effectRef idx="2">
+            <a:schemeClr val="accent1"/>
+          </a:effectRef>
+          <a:fontRef idx="minor">
+            <a:schemeClr val="lt1"/>
+          </a:fontRef>
+        </p:style>
+        <p:txBody>
+          <a:bodyPr rtlCol="0" anchor="ctr"/>
+          <a:lstStyle/>
+          <a:p>
+            <a:pPr algn="ctr"/>
+          </a:p>
+        </p:txBody>
+      </p:sp>
+      <p:sp>
+        <p:nvSpPr>
+          <p:cNvPr id="15" name="TextBox 14"/>
+          <p:cNvSpPr txBox="1"/>
+          <p:nvPr/>
+        </p:nvSpPr>
+        <p:spPr>
+          <a:xfrm>
+            <a:off x="6505955" y="1737360"/>
+            <a:ext cx="4677156" cy="457200"/>
+          </a:xfrm>
+          <a:prstGeom prst="rect">
+            <a:avLst/>
+          </a:prstGeom>
+          <a:noFill/>
+        </p:spPr>
+        <p:txBody>
+          <a:bodyPr wrap="square" anchor="ctr" lIns="0" rIns="0">
+            <a:spAutoFit/>
+          </a:bodyPr>
+          <a:lstStyle/>
+          <a:p>
+            <a:pPr algn="l"/>
+            <a:r>
+              <a:rPr sz="1800" b="1" i="0">
+                <a:solidFill>
+                  <a:srgbClr val="A371F7"/>
+                </a:solidFill>
+                <a:latin typeface="Segoe UI"/>
+                <a:ea typeface="Segoe UI"/>
+                <a:cs typeface="Segoe UI"/>
+              </a:rPr>
+              <a:t>Prompts to the Copilot agent</a:t>
+            </a:r>
+          </a:p>
+        </p:txBody>
+      </p:sp>
+      <p:sp>
+        <p:nvSpPr>
+          <p:cNvPr id="16" name="TextBox 15"/>
+          <p:cNvSpPr txBox="1"/>
+          <p:nvPr/>
+        </p:nvSpPr>
+        <p:spPr>
+          <a:xfrm>
+            <a:off x="6505955" y="2240280"/>
+            <a:ext cx="4677156" cy="1188720"/>
+          </a:xfrm>
+          <a:prstGeom prst="rect">
+            <a:avLst/>
+          </a:prstGeom>
+          <a:noFill/>
+        </p:spPr>
+        <p:txBody>
+          <a:bodyPr wrap="square" anchor="t" lIns="0" rIns="0">
+            <a:spAutoFit/>
+          </a:bodyPr>
+          <a:lstStyle/>
+          <a:p>
+            <a:pPr algn="l">
+              <a:lnSpc>
+                <a:spcPct val="125000"/>
+              </a:lnSpc>
+            </a:pPr>
+            <a:r>
+              <a:rPr sz="1400" b="1" i="0">
+                <a:solidFill>
+                  <a:srgbClr val="A371F7"/>
+                </a:solidFill>
+                <a:latin typeface="Segoe UI"/>
+                <a:ea typeface="Segoe UI"/>
+                <a:cs typeface="Segoe UI"/>
+              </a:rPr>
+              <a:t>›  </a:t>
+            </a:r>
+            <a:r>
+              <a:rPr sz="1400" b="0" i="0">
+                <a:solidFill>
+                  <a:srgbClr val="E6EDF3"/>
+                </a:solidFill>
+                <a:latin typeface="Segoe UI"/>
+                <a:ea typeface="Segoe UI"/>
+                <a:cs typeface="Segoe UI"/>
+              </a:rPr>
+              <a:t>Deploy the template to a nominated repo</a:t>
+            </a:r>
+          </a:p>
+          <a:p>
+            <a:pPr algn="l">
+              <a:lnSpc>
+                <a:spcPct val="125000"/>
+              </a:lnSpc>
+            </a:pPr>
+            <a:r>
+              <a:rPr sz="1400" b="1" i="0">
+                <a:solidFill>
+                  <a:srgbClr val="A371F7"/>
+                </a:solidFill>
+                <a:latin typeface="Segoe UI"/>
+                <a:ea typeface="Segoe UI"/>
+                <a:cs typeface="Segoe UI"/>
+              </a:rPr>
+              <a:t>›  </a:t>
+            </a:r>
+            <a:r>
+              <a:rPr sz="1400" b="0" i="0">
+                <a:solidFill>
+                  <a:srgbClr val="E6EDF3"/>
+                </a:solidFill>
+                <a:latin typeface="Segoe UI"/>
+                <a:ea typeface="Segoe UI"/>
+                <a:cs typeface="Segoe UI"/>
+              </a:rPr>
+              <a:t>Update the template (asks before it pushes)</a:t>
+            </a:r>
+          </a:p>
+          <a:p>
+            <a:pPr algn="l">
+              <a:lnSpc>
+                <a:spcPct val="125000"/>
+              </a:lnSpc>
+            </a:pPr>
+            <a:r>
+              <a:rPr sz="1400" b="1" i="0">
+                <a:solidFill>
+                  <a:srgbClr val="A371F7"/>
+                </a:solidFill>
+                <a:latin typeface="Segoe UI"/>
+                <a:ea typeface="Segoe UI"/>
+                <a:cs typeface="Segoe UI"/>
+              </a:rPr>
+              <a:t>›  </a:t>
+            </a:r>
+            <a:r>
+              <a:rPr sz="1400" b="0" i="0">
+                <a:solidFill>
+                  <a:srgbClr val="E6EDF3"/>
+                </a:solidFill>
+                <a:latin typeface="Segoe UI"/>
+                <a:ea typeface="Segoe UI"/>
+                <a:cs typeface="Segoe UI"/>
+              </a:rPr>
+              <a:t>Explain the Assessment Report</a:t>
+            </a:r>
+          </a:p>
+          <a:p>
+            <a:pPr algn="l">
+              <a:lnSpc>
+                <a:spcPct val="125000"/>
+              </a:lnSpc>
+            </a:pPr>
+            <a:r>
+              <a:rPr sz="1400" b="1" i="0">
+                <a:solidFill>
+                  <a:srgbClr val="A371F7"/>
+                </a:solidFill>
+                <a:latin typeface="Segoe UI"/>
+                <a:ea typeface="Segoe UI"/>
+                <a:cs typeface="Segoe UI"/>
+              </a:rPr>
+              <a:t>›  </a:t>
+            </a:r>
+            <a:r>
+              <a:rPr sz="1400" b="0" i="0">
+                <a:solidFill>
+                  <a:srgbClr val="E6EDF3"/>
+                </a:solidFill>
+                <a:latin typeface="Segoe UI"/>
+                <a:ea typeface="Segoe UI"/>
+                <a:cs typeface="Segoe UI"/>
+              </a:rPr>
+              <a:t>Troubleshoot a failed job</a:t>
+            </a:r>
+          </a:p>
+        </p:txBody>
+      </p:sp>
+      <p:sp>
+        <p:nvSpPr>
+          <p:cNvPr id="17" name="Rounded Rectangle 16"/>
+          <p:cNvSpPr/>
+          <p:nvPr/>
+        </p:nvSpPr>
+        <p:spPr>
+          <a:xfrm>
+            <a:off x="758952" y="3922776"/>
+            <a:ext cx="3392424" cy="1600200"/>
+          </a:xfrm>
+          <a:prstGeom prst="roundRect">
+            <a:avLst>
+              <a:gd name="adj" fmla="val 6857"/>
+            </a:avLst>
+          </a:prstGeom>
+          <a:solidFill>
+            <a:srgbClr val="000000">
+              <a:alpha val="40000"/>
+            </a:srgbClr>
+          </a:solidFill>
+          <a:ln>
+            <a:noFill/>
+          </a:ln>
+          <a:effectLst/>
+        </p:spPr>
+        <p:style>
+          <a:lnRef idx="1">
+            <a:schemeClr val="accent1"/>
+          </a:lnRef>
+          <a:fillRef idx="3">
+            <a:schemeClr val="accent1"/>
+          </a:fillRef>
+          <a:effectRef idx="2">
+            <a:schemeClr val="accent1"/>
+          </a:effectRef>
+          <a:fontRef idx="minor">
+            <a:schemeClr val="lt1"/>
+          </a:fontRef>
+        </p:style>
+        <p:txBody>
+          <a:bodyPr rtlCol="0" anchor="ctr"/>
+          <a:lstStyle/>
+          <a:p>
+            <a:pPr algn="ctr"/>
+          </a:p>
+        </p:txBody>
+      </p:sp>
+      <p:sp>
+        <p:nvSpPr>
+          <p:cNvPr id="18" name="Rounded Rectangle 17"/>
+          <p:cNvSpPr/>
+          <p:nvPr/>
+        </p:nvSpPr>
+        <p:spPr>
+          <a:xfrm>
+            <a:off x="731520" y="3886200"/>
+            <a:ext cx="3392424" cy="1600200"/>
+          </a:xfrm>
+          <a:prstGeom prst="roundRect">
+            <a:avLst>
+              <a:gd name="adj" fmla="val 6857"/>
+            </a:avLst>
+          </a:prstGeom>
+          <a:solidFill>
+            <a:srgbClr val="21262D"/>
+          </a:solidFill>
+          <a:ln w="6350">
+            <a:solidFill>
+              <a:srgbClr val="30363D"/>
+            </a:solidFill>
+          </a:ln>
+          <a:effectLst/>
+        </p:spPr>
+        <p:style>
+          <a:lnRef idx="1">
+            <a:schemeClr val="accent1"/>
+          </a:lnRef>
+          <a:fillRef idx="3">
+            <a:schemeClr val="accent1"/>
+          </a:fillRef>
+          <a:effectRef idx="2">
+            <a:schemeClr val="accent1"/>
+          </a:effectRef>
+          <a:fontRef idx="minor">
+            <a:schemeClr val="lt1"/>
+          </a:fontRef>
+        </p:style>
+        <p:txBody>
+          <a:bodyPr rtlCol="0" anchor="ctr"/>
+          <a:lstStyle/>
+          <a:p>
+            <a:pPr algn="ctr"/>
+          </a:p>
+        </p:txBody>
+      </p:sp>
+      <p:sp>
+        <p:nvSpPr>
+          <p:cNvPr id="19" name="Rectangle 18"/>
+          <p:cNvSpPr/>
+          <p:nvPr/>
+        </p:nvSpPr>
+        <p:spPr>
+          <a:xfrm>
+            <a:off x="868680" y="3886200"/>
+            <a:ext cx="3118104" cy="36576"/>
+          </a:xfrm>
+          <a:prstGeom prst="rect">
+            <a:avLst/>
+          </a:prstGeom>
+          <a:solidFill>
+            <a:srgbClr val="58A6FF"/>
+          </a:solidFill>
+          <a:ln>
+            <a:noFill/>
+          </a:ln>
+          <a:effectLst/>
+        </p:spPr>
+        <p:style>
+          <a:lnRef idx="1">
+            <a:schemeClr val="accent1"/>
+          </a:lnRef>
+          <a:fillRef idx="3">
+            <a:schemeClr val="accent1"/>
+          </a:fillRef>
+          <a:effectRef idx="2">
+            <a:schemeClr val="accent1"/>
+          </a:effectRef>
+          <a:fontRef idx="minor">
+            <a:schemeClr val="lt1"/>
+          </a:fontRef>
+        </p:style>
+        <p:txBody>
+          <a:bodyPr rtlCol="0" anchor="ctr"/>
+          <a:lstStyle/>
+          <a:p>
+            <a:pPr algn="ctr"/>
+          </a:p>
+        </p:txBody>
+      </p:sp>
+      <p:sp>
+        <p:nvSpPr>
+          <p:cNvPr id="20" name="TextBox 19"/>
+          <p:cNvSpPr txBox="1"/>
+          <p:nvPr/>
+        </p:nvSpPr>
+        <p:spPr>
+          <a:xfrm>
+            <a:off x="914400" y="3995928"/>
+            <a:ext cx="3026664" cy="640080"/>
+          </a:xfrm>
+          <a:prstGeom prst="rect">
+            <a:avLst/>
+          </a:prstGeom>
+          <a:noFill/>
+        </p:spPr>
+        <p:txBody>
+          <a:bodyPr wrap="square" anchor="ctr" lIns="0" rIns="0">
+            <a:spAutoFit/>
+          </a:bodyPr>
+          <a:lstStyle/>
+          <a:p>
+            <a:pPr algn="ctr"/>
+            <a:r>
+              <a:rPr sz="3000" b="1" i="0">
+                <a:solidFill>
+                  <a:srgbClr val="58A6FF"/>
+                </a:solidFill>
+                <a:latin typeface="Segoe UI"/>
+                <a:ea typeface="Segoe UI"/>
+                <a:cs typeface="Segoe UI"/>
+              </a:rPr>
+              <a:t>~200</a:t>
+            </a:r>
+          </a:p>
+        </p:txBody>
+      </p:sp>
+      <p:sp>
+        <p:nvSpPr>
+          <p:cNvPr id="21" name="TextBox 20"/>
+          <p:cNvSpPr txBox="1"/>
+          <p:nvPr/>
+        </p:nvSpPr>
+        <p:spPr>
+          <a:xfrm>
+            <a:off x="914400" y="4636008"/>
+            <a:ext cx="3026664" cy="320040"/>
+          </a:xfrm>
+          <a:prstGeom prst="rect">
+            <a:avLst/>
+          </a:prstGeom>
+          <a:noFill/>
+        </p:spPr>
+        <p:txBody>
+          <a:bodyPr wrap="square" anchor="ctr" lIns="0" rIns="0">
+            <a:spAutoFit/>
+          </a:bodyPr>
+          <a:lstStyle/>
+          <a:p>
+            <a:pPr algn="ctr"/>
+            <a:r>
+              <a:rPr sz="1400" b="1" i="0">
+                <a:solidFill>
+                  <a:srgbClr val="E6EDF3"/>
+                </a:solidFill>
+                <a:latin typeface="Segoe UI"/>
+                <a:ea typeface="Segoe UI"/>
+                <a:cs typeface="Segoe UI"/>
+              </a:rPr>
+              <a:t>AI credits per full run</a:t>
+            </a:r>
+          </a:p>
+        </p:txBody>
+      </p:sp>
+      <p:sp>
+        <p:nvSpPr>
+          <p:cNvPr id="22" name="TextBox 21"/>
+          <p:cNvSpPr txBox="1"/>
+          <p:nvPr/>
+        </p:nvSpPr>
+        <p:spPr>
+          <a:xfrm>
+            <a:off x="914400" y="4956048"/>
+            <a:ext cx="3026664" cy="411480"/>
+          </a:xfrm>
+          <a:prstGeom prst="rect">
+            <a:avLst/>
+          </a:prstGeom>
+          <a:noFill/>
+        </p:spPr>
+        <p:txBody>
+          <a:bodyPr wrap="square" anchor="t" lIns="0" rIns="0">
+            <a:spAutoFit/>
+          </a:bodyPr>
+          <a:lstStyle/>
+          <a:p>
+            <a:pPr algn="ctr"/>
+            <a:r>
+              <a:rPr sz="1200" b="0" i="0">
+                <a:solidFill>
+                  <a:srgbClr val="8B949E"/>
+                </a:solidFill>
+                <a:latin typeface="Segoe UI"/>
+                <a:ea typeface="Segoe UI"/>
+                <a:cs typeface="Segoe UI"/>
+              </a:rPr>
+              <a:t>about $2, incl. gh-aw threat detection</a:t>
+            </a:r>
+          </a:p>
+        </p:txBody>
+      </p:sp>
+      <p:sp>
+        <p:nvSpPr>
+          <p:cNvPr id="23" name="Rounded Rectangle 22"/>
+          <p:cNvSpPr/>
+          <p:nvPr/>
+        </p:nvSpPr>
+        <p:spPr>
+          <a:xfrm>
+            <a:off x="4425696" y="3922776"/>
+            <a:ext cx="3392424" cy="1600200"/>
+          </a:xfrm>
+          <a:prstGeom prst="roundRect">
+            <a:avLst>
+              <a:gd name="adj" fmla="val 6857"/>
+            </a:avLst>
+          </a:prstGeom>
+          <a:solidFill>
+            <a:srgbClr val="000000">
+              <a:alpha val="40000"/>
+            </a:srgbClr>
+          </a:solidFill>
+          <a:ln>
+            <a:noFill/>
+          </a:ln>
+          <a:effectLst/>
+        </p:spPr>
+        <p:style>
+          <a:lnRef idx="1">
+            <a:schemeClr val="accent1"/>
+          </a:lnRef>
+          <a:fillRef idx="3">
+            <a:schemeClr val="accent1"/>
+          </a:fillRef>
+          <a:effectRef idx="2">
+            <a:schemeClr val="accent1"/>
+          </a:effectRef>
+          <a:fontRef idx="minor">
+            <a:schemeClr val="lt1"/>
+          </a:fontRef>
+        </p:style>
+        <p:txBody>
+          <a:bodyPr rtlCol="0" anchor="ctr"/>
+          <a:lstStyle/>
+          <a:p>
+            <a:pPr algn="ctr"/>
+          </a:p>
+        </p:txBody>
+      </p:sp>
+      <p:sp>
+        <p:nvSpPr>
+          <p:cNvPr id="24" name="Rounded Rectangle 23"/>
+          <p:cNvSpPr/>
+          <p:nvPr/>
+        </p:nvSpPr>
+        <p:spPr>
+          <a:xfrm>
+            <a:off x="4398264" y="3886200"/>
+            <a:ext cx="3392424" cy="1600200"/>
+          </a:xfrm>
+          <a:prstGeom prst="roundRect">
+            <a:avLst>
+              <a:gd name="adj" fmla="val 6857"/>
+            </a:avLst>
+          </a:prstGeom>
+          <a:solidFill>
+            <a:srgbClr val="21262D"/>
+          </a:solidFill>
+          <a:ln w="6350">
+            <a:solidFill>
+              <a:srgbClr val="30363D"/>
+            </a:solidFill>
+          </a:ln>
+          <a:effectLst/>
+        </p:spPr>
+        <p:style>
+          <a:lnRef idx="1">
+            <a:schemeClr val="accent1"/>
+          </a:lnRef>
+          <a:fillRef idx="3">
+            <a:schemeClr val="accent1"/>
+          </a:fillRef>
+          <a:effectRef idx="2">
+            <a:schemeClr val="accent1"/>
+          </a:effectRef>
+          <a:fontRef idx="minor">
+            <a:schemeClr val="lt1"/>
+          </a:fontRef>
+        </p:style>
+        <p:txBody>
+          <a:bodyPr rtlCol="0" anchor="ctr"/>
+          <a:lstStyle/>
+          <a:p>
+            <a:pPr algn="ctr"/>
+          </a:p>
+        </p:txBody>
+      </p:sp>
+      <p:sp>
+        <p:nvSpPr>
+          <p:cNvPr id="25" name="Rectangle 24"/>
+          <p:cNvSpPr/>
+          <p:nvPr/>
+        </p:nvSpPr>
+        <p:spPr>
+          <a:xfrm>
+            <a:off x="4535424" y="3886200"/>
+            <a:ext cx="3118104" cy="36576"/>
+          </a:xfrm>
+          <a:prstGeom prst="rect">
+            <a:avLst/>
+          </a:prstGeom>
+          <a:solidFill>
+            <a:srgbClr val="3FB950"/>
+          </a:solidFill>
+          <a:ln>
+            <a:noFill/>
+          </a:ln>
+          <a:effectLst/>
+        </p:spPr>
+        <p:style>
+          <a:lnRef idx="1">
+            <a:schemeClr val="accent1"/>
+          </a:lnRef>
+          <a:fillRef idx="3">
+            <a:schemeClr val="accent1"/>
+          </a:fillRef>
+          <a:effectRef idx="2">
+            <a:schemeClr val="accent1"/>
+          </a:effectRef>
+          <a:fontRef idx="minor">
+            <a:schemeClr val="lt1"/>
+          </a:fontRef>
+        </p:style>
+        <p:txBody>
+          <a:bodyPr rtlCol="0" anchor="ctr"/>
+          <a:lstStyle/>
+          <a:p>
+            <a:pPr algn="ctr"/>
+          </a:p>
+        </p:txBody>
+      </p:sp>
+      <p:sp>
+        <p:nvSpPr>
+          <p:cNvPr id="26" name="TextBox 25"/>
+          <p:cNvSpPr txBox="1"/>
+          <p:nvPr/>
+        </p:nvSpPr>
+        <p:spPr>
+          <a:xfrm>
+            <a:off x="4581144" y="3995928"/>
+            <a:ext cx="3026664" cy="640080"/>
+          </a:xfrm>
+          <a:prstGeom prst="rect">
+            <a:avLst/>
+          </a:prstGeom>
+          <a:noFill/>
+        </p:spPr>
+        <p:txBody>
+          <a:bodyPr wrap="square" anchor="ctr" lIns="0" rIns="0">
+            <a:spAutoFit/>
+          </a:bodyPr>
+          <a:lstStyle/>
+          <a:p>
+            <a:pPr algn="ctr"/>
+            <a:r>
+              <a:rPr sz="3000" b="1" i="0">
+                <a:solidFill>
+                  <a:srgbClr val="3FB950"/>
+                </a:solidFill>
+                <a:latin typeface="Segoe UI"/>
+                <a:ea typeface="Segoe UI"/>
+                <a:cs typeface="Segoe UI"/>
+              </a:rPr>
+              <a:t>~85 min</a:t>
+            </a:r>
+          </a:p>
+        </p:txBody>
+      </p:sp>
+      <p:sp>
+        <p:nvSpPr>
+          <p:cNvPr id="27" name="TextBox 26"/>
+          <p:cNvSpPr txBox="1"/>
+          <p:nvPr/>
+        </p:nvSpPr>
+        <p:spPr>
+          <a:xfrm>
+            <a:off x="4581144" y="4636008"/>
+            <a:ext cx="3026664" cy="320040"/>
+          </a:xfrm>
+          <a:prstGeom prst="rect">
+            <a:avLst/>
+          </a:prstGeom>
+          <a:noFill/>
+        </p:spPr>
+        <p:txBody>
+          <a:bodyPr wrap="square" anchor="ctr" lIns="0" rIns="0">
+            <a:spAutoFit/>
+          </a:bodyPr>
+          <a:lstStyle/>
+          <a:p>
+            <a:pPr algn="ctr"/>
+            <a:r>
+              <a:rPr sz="1400" b="1" i="0">
+                <a:solidFill>
+                  <a:srgbClr val="E6EDF3"/>
+                </a:solidFill>
+                <a:latin typeface="Segoe UI"/>
+                <a:ea typeface="Segoe UI"/>
+                <a:cs typeface="Segoe UI"/>
+              </a:rPr>
+              <a:t>GitHub Actions runner time</a:t>
+            </a:r>
+          </a:p>
+        </p:txBody>
+      </p:sp>
+      <p:sp>
+        <p:nvSpPr>
+          <p:cNvPr id="28" name="TextBox 27"/>
+          <p:cNvSpPr txBox="1"/>
+          <p:nvPr/>
+        </p:nvSpPr>
+        <p:spPr>
+          <a:xfrm>
+            <a:off x="4581144" y="4956048"/>
+            <a:ext cx="3026664" cy="411480"/>
+          </a:xfrm>
+          <a:prstGeom prst="rect">
+            <a:avLst/>
+          </a:prstGeom>
+          <a:noFill/>
+        </p:spPr>
+        <p:txBody>
+          <a:bodyPr wrap="square" anchor="t" lIns="0" rIns="0">
+            <a:spAutoFit/>
+          </a:bodyPr>
+          <a:lstStyle/>
+          <a:p>
+            <a:pPr algn="ctr"/>
+            <a:r>
+              <a:rPr sz="1200" b="0" i="0">
+                <a:solidFill>
+                  <a:srgbClr val="8B949E"/>
+                </a:solidFill>
+                <a:latin typeface="Segoe UI"/>
+                <a:ea typeface="Segoe UI"/>
+                <a:cs typeface="Segoe UI"/>
+              </a:rPr>
+              <a:t>free on a public repo; $0.006/min if private</a:t>
+            </a:r>
+          </a:p>
+        </p:txBody>
+      </p:sp>
+      <p:sp>
+        <p:nvSpPr>
+          <p:cNvPr id="29" name="Rounded Rectangle 28"/>
+          <p:cNvSpPr/>
+          <p:nvPr/>
+        </p:nvSpPr>
+        <p:spPr>
+          <a:xfrm>
+            <a:off x="8092440" y="3922776"/>
+            <a:ext cx="3392424" cy="1600200"/>
+          </a:xfrm>
+          <a:prstGeom prst="roundRect">
+            <a:avLst>
+              <a:gd name="adj" fmla="val 6857"/>
+            </a:avLst>
+          </a:prstGeom>
+          <a:solidFill>
+            <a:srgbClr val="000000">
+              <a:alpha val="40000"/>
+            </a:srgbClr>
+          </a:solidFill>
+          <a:ln>
+            <a:noFill/>
+          </a:ln>
+          <a:effectLst/>
+        </p:spPr>
+        <p:style>
+          <a:lnRef idx="1">
+            <a:schemeClr val="accent1"/>
+          </a:lnRef>
+          <a:fillRef idx="3">
+            <a:schemeClr val="accent1"/>
+          </a:fillRef>
+          <a:effectRef idx="2">
+            <a:schemeClr val="accent1"/>
+          </a:effectRef>
+          <a:fontRef idx="minor">
+            <a:schemeClr val="lt1"/>
+          </a:fontRef>
+        </p:style>
+        <p:txBody>
+          <a:bodyPr rtlCol="0" anchor="ctr"/>
+          <a:lstStyle/>
+          <a:p>
+            <a:pPr algn="ctr"/>
+          </a:p>
+        </p:txBody>
+      </p:sp>
+      <p:sp>
+        <p:nvSpPr>
+          <p:cNvPr id="30" name="Rounded Rectangle 29"/>
+          <p:cNvSpPr/>
+          <p:nvPr/>
+        </p:nvSpPr>
+        <p:spPr>
+          <a:xfrm>
+            <a:off x="8065008" y="3886200"/>
+            <a:ext cx="3392424" cy="1600200"/>
+          </a:xfrm>
+          <a:prstGeom prst="roundRect">
+            <a:avLst>
+              <a:gd name="adj" fmla="val 6857"/>
+            </a:avLst>
+          </a:prstGeom>
+          <a:solidFill>
+            <a:srgbClr val="21262D"/>
+          </a:solidFill>
+          <a:ln w="6350">
+            <a:solidFill>
+              <a:srgbClr val="30363D"/>
+            </a:solidFill>
+          </a:ln>
+          <a:effectLst/>
+        </p:spPr>
+        <p:style>
+          <a:lnRef idx="1">
+            <a:schemeClr val="accent1"/>
+          </a:lnRef>
+          <a:fillRef idx="3">
+            <a:schemeClr val="accent1"/>
+          </a:fillRef>
+          <a:effectRef idx="2">
+            <a:schemeClr val="accent1"/>
+          </a:effectRef>
+          <a:fontRef idx="minor">
+            <a:schemeClr val="lt1"/>
+          </a:fontRef>
+        </p:style>
+        <p:txBody>
+          <a:bodyPr rtlCol="0" anchor="ctr"/>
+          <a:lstStyle/>
+          <a:p>
+            <a:pPr algn="ctr"/>
+          </a:p>
+        </p:txBody>
+      </p:sp>
+      <p:sp>
+        <p:nvSpPr>
+          <p:cNvPr id="31" name="Rectangle 30"/>
+          <p:cNvSpPr/>
+          <p:nvPr/>
+        </p:nvSpPr>
+        <p:spPr>
+          <a:xfrm>
+            <a:off x="8202168" y="3886200"/>
+            <a:ext cx="3118104" cy="36576"/>
+          </a:xfrm>
+          <a:prstGeom prst="rect">
+            <a:avLst/>
+          </a:prstGeom>
+          <a:solidFill>
+            <a:srgbClr val="D29922"/>
+          </a:solidFill>
+          <a:ln>
+            <a:noFill/>
+          </a:ln>
+          <a:effectLst/>
+        </p:spPr>
+        <p:style>
+          <a:lnRef idx="1">
+            <a:schemeClr val="accent1"/>
+          </a:lnRef>
+          <a:fillRef idx="3">
+            <a:schemeClr val="accent1"/>
+          </a:fillRef>
+          <a:effectRef idx="2">
+            <a:schemeClr val="accent1"/>
+          </a:effectRef>
+          <a:fontRef idx="minor">
+            <a:schemeClr val="lt1"/>
+          </a:fontRef>
+        </p:style>
+        <p:txBody>
+          <a:bodyPr rtlCol="0" anchor="ctr"/>
+          <a:lstStyle/>
+          <a:p>
+            <a:pPr algn="ctr"/>
+          </a:p>
+        </p:txBody>
+      </p:sp>
+      <p:sp>
+        <p:nvSpPr>
+          <p:cNvPr id="32" name="TextBox 31"/>
+          <p:cNvSpPr txBox="1"/>
+          <p:nvPr/>
+        </p:nvSpPr>
+        <p:spPr>
+          <a:xfrm>
+            <a:off x="8247888" y="3995928"/>
+            <a:ext cx="3026664" cy="640080"/>
+          </a:xfrm>
+          <a:prstGeom prst="rect">
+            <a:avLst/>
+          </a:prstGeom>
+          <a:noFill/>
+        </p:spPr>
+        <p:txBody>
+          <a:bodyPr wrap="square" anchor="ctr" lIns="0" rIns="0">
+            <a:spAutoFit/>
+          </a:bodyPr>
+          <a:lstStyle/>
+          <a:p>
+            <a:pPr algn="ctr"/>
+            <a:r>
+              <a:rPr sz="3000" b="1" i="0">
+                <a:solidFill>
+                  <a:srgbClr val="D29922"/>
+                </a:solidFill>
+                <a:latin typeface="Segoe UI"/>
+                <a:ea typeface="Segoe UI"/>
+                <a:cs typeface="Segoe UI"/>
+              </a:rPr>
+              <a:t>Est. → Actual</a:t>
+            </a:r>
+          </a:p>
+        </p:txBody>
+      </p:sp>
+      <p:sp>
+        <p:nvSpPr>
+          <p:cNvPr id="33" name="TextBox 32"/>
+          <p:cNvSpPr txBox="1"/>
+          <p:nvPr/>
+        </p:nvSpPr>
+        <p:spPr>
+          <a:xfrm>
+            <a:off x="8247888" y="4636008"/>
+            <a:ext cx="3026664" cy="320040"/>
+          </a:xfrm>
+          <a:prstGeom prst="rect">
+            <a:avLst/>
+          </a:prstGeom>
+          <a:noFill/>
+        </p:spPr>
+        <p:txBody>
+          <a:bodyPr wrap="square" anchor="ctr" lIns="0" rIns="0">
+            <a:spAutoFit/>
+          </a:bodyPr>
+          <a:lstStyle/>
+          <a:p>
+            <a:pPr algn="ctr"/>
+            <a:r>
+              <a:rPr sz="1400" b="1" i="0">
+                <a:solidFill>
+                  <a:srgbClr val="E6EDF3"/>
+                </a:solidFill>
+                <a:latin typeface="Segoe UI"/>
+                <a:ea typeface="Segoe UI"/>
+                <a:cs typeface="Segoe UI"/>
+              </a:rPr>
+              <a:t>cost of every stage</a:t>
+            </a:r>
+          </a:p>
+        </p:txBody>
+      </p:sp>
+      <p:sp>
+        <p:nvSpPr>
+          <p:cNvPr id="34" name="TextBox 33"/>
+          <p:cNvSpPr txBox="1"/>
+          <p:nvPr/>
+        </p:nvSpPr>
+        <p:spPr>
+          <a:xfrm>
+            <a:off x="8247888" y="4956048"/>
+            <a:ext cx="3026664" cy="411480"/>
+          </a:xfrm>
+          <a:prstGeom prst="rect">
+            <a:avLst/>
+          </a:prstGeom>
+          <a:noFill/>
+        </p:spPr>
+        <p:txBody>
+          <a:bodyPr wrap="square" anchor="t" lIns="0" rIns="0">
+            <a:spAutoFit/>
+          </a:bodyPr>
+          <a:lstStyle/>
+          <a:p>
+            <a:pPr algn="ctr"/>
+            <a:r>
+              <a:rPr sz="1200" b="0" i="0">
+                <a:solidFill>
+                  <a:srgbClr val="8B949E"/>
+                </a:solidFill>
+                <a:latin typeface="Segoe UI"/>
+                <a:ea typeface="Segoe UI"/>
+                <a:cs typeface="Segoe UI"/>
+              </a:rPr>
+              <a:t>estimated at gate 1, compared before gate 3</a:t>
+            </a:r>
+          </a:p>
+        </p:txBody>
+      </p:sp>
+      <p:sp>
+        <p:nvSpPr>
+          <p:cNvPr id="35" name="TextBox 34"/>
+          <p:cNvSpPr txBox="1"/>
+          <p:nvPr/>
+        </p:nvSpPr>
+        <p:spPr>
+          <a:xfrm>
+            <a:off x="731520" y="5897880"/>
+            <a:ext cx="10725912" cy="365760"/>
+          </a:xfrm>
+          <a:prstGeom prst="rect">
+            <a:avLst/>
+          </a:prstGeom>
+          <a:noFill/>
+        </p:spPr>
+        <p:txBody>
+          <a:bodyPr wrap="square" anchor="ctr">
+            <a:spAutoFit/>
+          </a:bodyPr>
+          <a:lstStyle/>
+          <a:p>
+            <a:pPr algn="ctr"/>
+            <a:r>
+              <a:rPr sz="1400" b="0" i="0">
+                <a:solidFill>
+                  <a:srgbClr val="8B949E"/>
+                </a:solidFill>
+                <a:latin typeface="Segoe UI"/>
+                <a:ea typeface="Segoe UI"/>
+                <a:cs typeface="Segoe UI"/>
+              </a:rPr>
+              <a:t>A demo built with gh-aw, not a product feature · same lifecycle order as GitHub Copilot app modernization</a:t>
+            </a:r>
+          </a:p>
+        </p:txBody>
+      </p:sp>
+    </p:spTree>
+  </p:cSld>
+  <p:clrMapOvr>
+    <a:masterClrMapping/>
+  </p:clrMapOvr>
+</p:sld>
+</file>
+
 <file path=ppt/slides/slide2.xml><?xml version="1.0" encoding="utf-8"?>
 <p:sld xmlns:a="http://schemas.openxmlformats.org/drawingml/2006/main" xmlns:r="http://schemas.openxmlformats.org/officeDocument/2006/relationships" xmlns:p="http://schemas.openxmlformats.org/presentationml/2006/main">
   <p:cSld name="Slide 2">
@@ -3005,7 +6177,7 @@
                 <a:ea typeface="Segoe UI" pitchFamily="34" charset="-122"/>
                 <a:cs typeface="Segoe UI" pitchFamily="34" charset="-120"/>
               </a:rPr>
-              <a:t>2 / 8</a:t>
+              <a:t>2 / 11</a:t>
             </a:r>
             <a:endParaRPr lang="en-US" sz="1000" dirty="0"/>
           </a:p>
@@ -3782,7 +6954,7 @@
                 <a:ea typeface="Segoe UI" pitchFamily="34" charset="-122"/>
                 <a:cs typeface="Segoe UI" pitchFamily="34" charset="-120"/>
               </a:rPr>
-              <a:t>3 / 8</a:t>
+              <a:t>3 / 11</a:t>
             </a:r>
             <a:endParaRPr lang="en-US" sz="1000" dirty="0"/>
           </a:p>
@@ -5038,7 +8210,7 @@
                 <a:ea typeface="Segoe UI" pitchFamily="34" charset="-122"/>
                 <a:cs typeface="Segoe UI" pitchFamily="34" charset="-120"/>
               </a:rPr>
-              <a:t>4 / 8</a:t>
+              <a:t>4 / 11</a:t>
             </a:r>
             <a:endParaRPr lang="en-US" sz="1000" dirty="0"/>
           </a:p>
@@ -6657,7 +9829,7 @@
                 <a:ea typeface="Segoe UI" pitchFamily="34" charset="-122"/>
                 <a:cs typeface="Segoe UI" pitchFamily="34" charset="-120"/>
               </a:rPr>
-              <a:t>5 / 8</a:t>
+              <a:t>5 / 11</a:t>
             </a:r>
             <a:endParaRPr lang="en-US" sz="1000" dirty="0"/>
           </a:p>
@@ -8601,7 +11773,7 @@
                 <a:ea typeface="Segoe UI" pitchFamily="34" charset="-122"/>
                 <a:cs typeface="Segoe UI" pitchFamily="34" charset="-120"/>
               </a:rPr>
-              <a:t>6 / 8</a:t>
+              <a:t>9 / 11</a:t>
             </a:r>
             <a:endParaRPr lang="en-US" sz="1000" dirty="0"/>
           </a:p>
@@ -10329,7 +13501,7 @@
                 <a:ea typeface="Segoe UI" pitchFamily="34" charset="-122"/>
                 <a:cs typeface="Segoe UI" pitchFamily="34" charset="-120"/>
               </a:rPr>
-              <a:t>7 / 8</a:t>
+              <a:t>10 / 11</a:t>
             </a:r>
             <a:endParaRPr lang="en-US" sz="1000" dirty="0"/>
           </a:p>
@@ -14529,6 +17701,392 @@
 </p:sld>
 </file>
 
+<file path=ppt/slides/slide9.xml><?xml version="1.0" encoding="utf-8"?>
+<p:sld xmlns:a="http://schemas.openxmlformats.org/drawingml/2006/main" xmlns:p="http://schemas.openxmlformats.org/presentationml/2006/main" xmlns:r="http://schemas.openxmlformats.org/officeDocument/2006/relationships">
+  <p:cSld>
+    <p:bg>
+      <p:bgPr>
+        <a:solidFill>
+          <a:srgbClr val="0D1117"/>
+        </a:solidFill>
+        <a:effectLst/>
+      </p:bgPr>
+    </p:bg>
+    <p:spTree>
+      <p:nvGrpSpPr>
+        <p:cNvPr id="1" name=""/>
+        <p:cNvGrpSpPr/>
+        <p:nvPr/>
+      </p:nvGrpSpPr>
+      <p:grpSpPr/>
+      <p:sp>
+        <p:nvSpPr>
+          <p:cNvPr id="2" name="Rectangle 1"/>
+          <p:cNvSpPr/>
+          <p:nvPr/>
+        </p:nvSpPr>
+        <p:spPr>
+          <a:xfrm>
+            <a:off x="0" y="0"/>
+            <a:ext cx="12191695" cy="36576"/>
+          </a:xfrm>
+          <a:prstGeom prst="rect">
+            <a:avLst/>
+          </a:prstGeom>
+          <a:solidFill>
+            <a:srgbClr val="238636"/>
+          </a:solidFill>
+          <a:ln>
+            <a:noFill/>
+          </a:ln>
+          <a:effectLst/>
+        </p:spPr>
+        <p:style>
+          <a:lnRef idx="1">
+            <a:schemeClr val="accent1"/>
+          </a:lnRef>
+          <a:fillRef idx="3">
+            <a:schemeClr val="accent1"/>
+          </a:fillRef>
+          <a:effectRef idx="2">
+            <a:schemeClr val="accent1"/>
+          </a:effectRef>
+          <a:fontRef idx="minor">
+            <a:schemeClr val="lt1"/>
+          </a:fontRef>
+        </p:style>
+        <p:txBody>
+          <a:bodyPr rtlCol="0" anchor="ctr"/>
+          <a:lstStyle/>
+          <a:p>
+            <a:pPr algn="ctr"/>
+          </a:p>
+        </p:txBody>
+      </p:sp>
+      <p:sp>
+        <p:nvSpPr>
+          <p:cNvPr id="3" name="TextBox 2"/>
+          <p:cNvSpPr txBox="1"/>
+          <p:nvPr/>
+        </p:nvSpPr>
+        <p:spPr>
+          <a:xfrm>
+            <a:off x="731520" y="6400800"/>
+            <a:ext cx="7315200" cy="320040"/>
+          </a:xfrm>
+          <a:prstGeom prst="rect">
+            <a:avLst/>
+          </a:prstGeom>
+          <a:noFill/>
+        </p:spPr>
+        <p:txBody>
+          <a:bodyPr wrap="square" anchor="ctr">
+            <a:spAutoFit/>
+          </a:bodyPr>
+          <a:lstStyle/>
+          <a:p>
+            <a:pPr algn="l"/>
+            <a:r>
+              <a:rPr sz="1000" b="0" i="0">
+                <a:solidFill>
+                  <a:srgbClr val="484F58"/>
+                </a:solidFill>
+                <a:latin typeface="Segoe UI"/>
+                <a:ea typeface="Segoe UI"/>
+                <a:cs typeface="Segoe UI"/>
+              </a:rPr>
+              <a:t>Innovate 2026  ·  ADO/GitHub with Microsoft</a:t>
+            </a:r>
+          </a:p>
+        </p:txBody>
+      </p:sp>
+      <p:sp>
+        <p:nvSpPr>
+          <p:cNvPr id="4" name="Text 2"/>
+          <p:cNvSpPr txBox="1"/>
+          <p:nvPr/>
+        </p:nvSpPr>
+        <p:spPr>
+          <a:xfrm>
+            <a:off x="11155680" y="6446520"/>
+            <a:ext cx="822960" cy="274320"/>
+          </a:xfrm>
+          <a:prstGeom prst="rect">
+            <a:avLst/>
+          </a:prstGeom>
+          <a:noFill/>
+        </p:spPr>
+        <p:txBody>
+          <a:bodyPr wrap="square" anchor="ctr">
+            <a:spAutoFit/>
+          </a:bodyPr>
+          <a:lstStyle/>
+          <a:p>
+            <a:pPr algn="r"/>
+            <a:r>
+              <a:rPr sz="1000" b="0" i="0">
+                <a:solidFill>
+                  <a:srgbClr val="484F58"/>
+                </a:solidFill>
+                <a:latin typeface="Segoe UI"/>
+                <a:ea typeface="Segoe UI"/>
+                <a:cs typeface="Segoe UI"/>
+              </a:rPr>
+              <a:t>6 / 11</a:t>
+            </a:r>
+          </a:p>
+        </p:txBody>
+      </p:sp>
+      <p:sp>
+        <p:nvSpPr>
+          <p:cNvPr id="5" name="TextBox 4"/>
+          <p:cNvSpPr txBox="1"/>
+          <p:nvPr/>
+        </p:nvSpPr>
+        <p:spPr>
+          <a:xfrm>
+            <a:off x="731520" y="320040"/>
+            <a:ext cx="10058400" cy="640080"/>
+          </a:xfrm>
+          <a:prstGeom prst="rect">
+            <a:avLst/>
+          </a:prstGeom>
+          <a:noFill/>
+        </p:spPr>
+        <p:txBody>
+          <a:bodyPr wrap="square" anchor="ctr">
+            <a:spAutoFit/>
+          </a:bodyPr>
+          <a:lstStyle/>
+          <a:p>
+            <a:pPr algn="l"/>
+            <a:r>
+              <a:rPr sz="3800" b="1" i="0">
+                <a:solidFill>
+                  <a:srgbClr val="E6EDF3"/>
+                </a:solidFill>
+                <a:latin typeface="Segoe UI"/>
+                <a:ea typeface="Segoe UI"/>
+                <a:cs typeface="Segoe UI"/>
+              </a:rPr>
+              <a:t>Demo: The Software Factory</a:t>
+            </a:r>
+          </a:p>
+        </p:txBody>
+      </p:sp>
+      <p:sp>
+        <p:nvSpPr>
+          <p:cNvPr id="6" name="TextBox 5"/>
+          <p:cNvSpPr txBox="1"/>
+          <p:nvPr/>
+        </p:nvSpPr>
+        <p:spPr>
+          <a:xfrm>
+            <a:off x="731520" y="914400"/>
+            <a:ext cx="10515600" cy="365760"/>
+          </a:xfrm>
+          <a:prstGeom prst="rect">
+            <a:avLst/>
+          </a:prstGeom>
+          <a:noFill/>
+        </p:spPr>
+        <p:txBody>
+          <a:bodyPr wrap="square" anchor="ctr">
+            <a:spAutoFit/>
+          </a:bodyPr>
+          <a:lstStyle/>
+          <a:p>
+            <a:pPr algn="l"/>
+            <a:r>
+              <a:rPr sz="1800" b="0" i="1">
+                <a:solidFill>
+                  <a:srgbClr val="8B949E"/>
+                </a:solidFill>
+                <a:latin typeface="Segoe UI"/>
+                <a:ea typeface="Segoe UI"/>
+                <a:cs typeface="Segoe UI"/>
+              </a:rPr>
+              <a:t>Beat 4 — one repository acts as the team and modernizes Java in the repos it nominates</a:t>
+            </a:r>
+          </a:p>
+        </p:txBody>
+      </p:sp>
+      <p:sp>
+        <p:nvSpPr>
+          <p:cNvPr id="7" name="Rounded Rectangle 6"/>
+          <p:cNvSpPr/>
+          <p:nvPr/>
+        </p:nvSpPr>
+        <p:spPr>
+          <a:xfrm>
+            <a:off x="758952" y="1591056"/>
+            <a:ext cx="10725912" cy="4096024"/>
+          </a:xfrm>
+          <a:prstGeom prst="roundRect">
+            <a:avLst>
+              <a:gd name="adj" fmla="val 2678"/>
+            </a:avLst>
+          </a:prstGeom>
+          <a:solidFill>
+            <a:srgbClr val="000000">
+              <a:alpha val="40000"/>
+            </a:srgbClr>
+          </a:solidFill>
+          <a:ln>
+            <a:noFill/>
+          </a:ln>
+          <a:effectLst/>
+        </p:spPr>
+        <p:style>
+          <a:lnRef idx="1">
+            <a:schemeClr val="accent1"/>
+          </a:lnRef>
+          <a:fillRef idx="3">
+            <a:schemeClr val="accent1"/>
+          </a:fillRef>
+          <a:effectRef idx="2">
+            <a:schemeClr val="accent1"/>
+          </a:effectRef>
+          <a:fontRef idx="minor">
+            <a:schemeClr val="lt1"/>
+          </a:fontRef>
+        </p:style>
+        <p:txBody>
+          <a:bodyPr rtlCol="0" anchor="ctr"/>
+          <a:lstStyle/>
+          <a:p>
+            <a:pPr algn="ctr"/>
+          </a:p>
+        </p:txBody>
+      </p:sp>
+      <p:sp>
+        <p:nvSpPr>
+          <p:cNvPr id="8" name="Rounded Rectangle 7"/>
+          <p:cNvSpPr/>
+          <p:nvPr/>
+        </p:nvSpPr>
+        <p:spPr>
+          <a:xfrm>
+            <a:off x="731520" y="1554480"/>
+            <a:ext cx="10725912" cy="4096024"/>
+          </a:xfrm>
+          <a:prstGeom prst="roundRect">
+            <a:avLst>
+              <a:gd name="adj" fmla="val 2678"/>
+            </a:avLst>
+          </a:prstGeom>
+          <a:solidFill>
+            <a:srgbClr val="161B22"/>
+          </a:solidFill>
+          <a:ln w="6350">
+            <a:solidFill>
+              <a:srgbClr val="30363D"/>
+            </a:solidFill>
+          </a:ln>
+          <a:effectLst/>
+        </p:spPr>
+        <p:style>
+          <a:lnRef idx="1">
+            <a:schemeClr val="accent1"/>
+          </a:lnRef>
+          <a:fillRef idx="3">
+            <a:schemeClr val="accent1"/>
+          </a:fillRef>
+          <a:effectRef idx="2">
+            <a:schemeClr val="accent1"/>
+          </a:effectRef>
+          <a:fontRef idx="minor">
+            <a:schemeClr val="lt1"/>
+          </a:fontRef>
+        </p:style>
+        <p:txBody>
+          <a:bodyPr rtlCol="0" anchor="ctr"/>
+          <a:lstStyle/>
+          <a:p>
+            <a:pPr algn="ctr"/>
+          </a:p>
+        </p:txBody>
+      </p:sp>
+      <p:pic>
+        <p:nvPicPr>
+          <p:cNvPr id="9" name="Picture 8" descr="beat-4-factory-dark.png"/>
+          <p:cNvPicPr>
+            <a:picLocks noChangeAspect="1"/>
+          </p:cNvPicPr>
+          <p:nvPr/>
+        </p:nvPicPr>
+        <p:blipFill>
+          <a:blip r:embed="rId2"/>
+          <a:stretch>
+            <a:fillRect/>
+          </a:stretch>
+        </p:blipFill>
+        <p:spPr>
+          <a:xfrm>
+            <a:off x="804672" y="1627632"/>
+            <a:ext cx="10579608" cy="3949720"/>
+          </a:xfrm>
+          <a:prstGeom prst="rect">
+            <a:avLst/>
+          </a:prstGeom>
+        </p:spPr>
+      </p:pic>
+      <p:sp>
+        <p:nvSpPr>
+          <p:cNvPr id="10" name="TextBox 9"/>
+          <p:cNvSpPr txBox="1"/>
+          <p:nvPr/>
+        </p:nvSpPr>
+        <p:spPr>
+          <a:xfrm>
+            <a:off x="731520" y="5897880"/>
+            <a:ext cx="10725912" cy="365760"/>
+          </a:xfrm>
+          <a:prstGeom prst="rect">
+            <a:avLst/>
+          </a:prstGeom>
+          <a:noFill/>
+        </p:spPr>
+        <p:txBody>
+          <a:bodyPr wrap="square" anchor="ctr">
+            <a:spAutoFit/>
+          </a:bodyPr>
+          <a:lstStyle/>
+          <a:p>
+            <a:pPr algn="ctr"/>
+            <a:r>
+              <a:rPr sz="1400" b="1" i="0">
+                <a:solidFill>
+                  <a:srgbClr val="3FB950"/>
+                </a:solidFill>
+                <a:latin typeface="Segoe UI"/>
+                <a:ea typeface="Segoe UI"/>
+                <a:cs typeface="Segoe UI"/>
+              </a:rPr>
+              <a:t>Factory = catalog + template + canvas</a:t>
+            </a:r>
+            <a:r>
+              <a:rPr sz="1400" b="0" i="0">
+                <a:solidFill>
+                  <a:srgbClr val="8B949E"/>
+                </a:solidFill>
+                <a:latin typeface="Segoe UI"/>
+                <a:ea typeface="Segoe UI"/>
+                <a:cs typeface="Segoe UI"/>
+              </a:rPr>
+              <a:t>   ·   Target: Asset Manager, Java 8 / Spring Boot 2.7 → Java 21</a:t>
+            </a:r>
+          </a:p>
+        </p:txBody>
+      </p:sp>
+    </p:spTree>
+  </p:cSld>
+  <p:clrMapOvr>
+    <a:masterClrMapping/>
+  </p:clrMapOvr>
+</p:sld>
+</file>
+
 <file path=ppt/theme/theme1.xml><?xml version="1.0" encoding="utf-8"?>
 <a:theme xmlns:a="http://schemas.openxmlformats.org/drawingml/2006/main" name="Office Theme">
   <a:themeElements>

</xml_diff>